<commit_message>
docs(deck): reframe slide 4 from limits to growth ladder; align the spoken line
Co-Authored-By: Claude Opus 5 <noreply@anthropic.com>
</commit_message>
<xml_diff>
--- a/docs/deck/pgfy-pitch.pptx
+++ b/docs/deck/pgfy-pitch.pptx
@@ -3452,7 +3452,7 @@
                 <a:ea typeface="Inter" pitchFamily="34" charset="-122"/>
                 <a:cs typeface="Inter" pitchFamily="34" charset="-120"/>
               </a:rPr>
-              <a:t>How far $12 goes — and where it stops</a:t>
+              <a:t>How far $12 goes — and how it grows</a:t>
             </a:r>
             <a:endParaRPr lang="en-US" sz="2900" dirty="0"/>
           </a:p>
@@ -3903,7 +3903,7 @@
         <p:spPr>
           <a:xfrm>
             <a:off x="749808" y="4251960"/>
-            <a:ext cx="960120" cy="265176"/>
+            <a:ext cx="1600200" cy="265176"/>
           </a:xfrm>
           <a:prstGeom prst="roundRect">
             <a:avLst>
@@ -3911,11 +3911,11 @@
             </a:avLst>
           </a:prstGeom>
           <a:solidFill>
-            <a:srgbClr val="30291D"/>
+            <a:srgbClr val="202E25"/>
           </a:solidFill>
           <a:ln w="12700">
             <a:solidFill>
-              <a:srgbClr val="30291D"/>
+              <a:srgbClr val="202E25"/>
             </a:solidFill>
             <a:prstDash val="solid"/>
           </a:ln>
@@ -3930,7 +3930,7 @@
         <p:spPr>
           <a:xfrm>
             <a:off x="749808" y="4251960"/>
-            <a:ext cx="960120" cy="265176"/>
+            <a:ext cx="1600200" cy="265176"/>
           </a:xfrm>
           <a:prstGeom prst="rect">
             <a:avLst/>
@@ -3950,13 +3950,13 @@
             <a:r>
               <a:rPr lang="en-US" sz="1000" b="1" dirty="0">
                 <a:solidFill>
-                  <a:srgbClr val="E6B866"/>
-                </a:solidFill>
-                <a:latin typeface="Inter" pitchFamily="34" charset="0"/>
-                <a:ea typeface="Inter" pitchFamily="34" charset="-122"/>
-                <a:cs typeface="Inter" pitchFamily="34" charset="-120"/>
-              </a:rPr>
-              <a:t>one node</a:t>
+                  <a:srgbClr val="8FC7A2"/>
+                </a:solidFill>
+                <a:latin typeface="Inter" pitchFamily="34" charset="0"/>
+                <a:ea typeface="Inter" pitchFamily="34" charset="-122"/>
+                <a:cs typeface="Inter" pitchFamily="34" charset="-120"/>
+              </a:rPr>
+              <a:t>daily backups, verified</a:t>
             </a:r>
             <a:endParaRPr lang="en-US" sz="1000" dirty="0"/>
           </a:p>
@@ -3970,8 +3970,8 @@
         </p:nvSpPr>
         <p:spPr>
           <a:xfrm>
-            <a:off x="1828800" y="4251960"/>
-            <a:ext cx="960120" cy="265176"/>
+            <a:off x="2468880" y="4251960"/>
+            <a:ext cx="1600200" cy="265176"/>
           </a:xfrm>
           <a:prstGeom prst="roundRect">
             <a:avLst>
@@ -3979,11 +3979,11 @@
             </a:avLst>
           </a:prstGeom>
           <a:solidFill>
-            <a:srgbClr val="30291D"/>
+            <a:srgbClr val="202E25"/>
           </a:solidFill>
           <a:ln w="12700">
             <a:solidFill>
-              <a:srgbClr val="30291D"/>
+              <a:srgbClr val="202E25"/>
             </a:solidFill>
             <a:prstDash val="solid"/>
           </a:ln>
@@ -3997,8 +3997,8 @@
         </p:nvSpPr>
         <p:spPr>
           <a:xfrm>
-            <a:off x="1828800" y="4251960"/>
-            <a:ext cx="960120" cy="265176"/>
+            <a:off x="2468880" y="4251960"/>
+            <a:ext cx="1600200" cy="265176"/>
           </a:xfrm>
           <a:prstGeom prst="rect">
             <a:avLst/>
@@ -4018,13 +4018,13 @@
             <a:r>
               <a:rPr lang="en-US" sz="1000" b="1" dirty="0">
                 <a:solidFill>
-                  <a:srgbClr val="E6B866"/>
-                </a:solidFill>
-                <a:latin typeface="Inter" pitchFamily="34" charset="0"/>
-                <a:ea typeface="Inter" pitchFamily="34" charset="-122"/>
-                <a:cs typeface="Inter" pitchFamily="34" charset="-120"/>
-              </a:rPr>
-              <a:t>24 h RPO</a:t>
+                  <a:srgbClr val="8FC7A2"/>
+                </a:solidFill>
+                <a:latin typeface="Inter" pitchFamily="34" charset="0"/>
+                <a:ea typeface="Inter" pitchFamily="34" charset="-122"/>
+                <a:cs typeface="Inter" pitchFamily="34" charset="-120"/>
+              </a:rPr>
+              <a:t>150 pooled connections</a:t>
             </a:r>
             <a:endParaRPr lang="en-US" sz="1000" dirty="0"/>
           </a:p>
@@ -4038,8 +4038,8 @@
         </p:nvSpPr>
         <p:spPr>
           <a:xfrm>
-            <a:off x="2907792" y="4251960"/>
-            <a:ext cx="1600200" cy="265176"/>
+            <a:off x="4187952" y="4251960"/>
+            <a:ext cx="1371600" cy="265176"/>
           </a:xfrm>
           <a:prstGeom prst="roundRect">
             <a:avLst>
@@ -4047,11 +4047,11 @@
             </a:avLst>
           </a:prstGeom>
           <a:solidFill>
-            <a:srgbClr val="30291D"/>
+            <a:srgbClr val="202E25"/>
           </a:solidFill>
           <a:ln w="12700">
             <a:solidFill>
-              <a:srgbClr val="30291D"/>
+              <a:srgbClr val="202E25"/>
             </a:solidFill>
             <a:prstDash val="solid"/>
           </a:ln>
@@ -4065,8 +4065,8 @@
         </p:nvSpPr>
         <p:spPr>
           <a:xfrm>
-            <a:off x="2907792" y="4251960"/>
-            <a:ext cx="1600200" cy="265176"/>
+            <a:off x="4187952" y="4251960"/>
+            <a:ext cx="1371600" cy="265176"/>
           </a:xfrm>
           <a:prstGeom prst="rect">
             <a:avLst/>
@@ -4086,13 +4086,13 @@
             <a:r>
               <a:rPr lang="en-US" sz="1000" b="1" dirty="0">
                 <a:solidFill>
-                  <a:srgbClr val="E6B866"/>
-                </a:solidFill>
-                <a:latin typeface="Inter" pitchFamily="34" charset="0"/>
-                <a:ea typeface="Inter" pitchFamily="34" charset="-122"/>
-                <a:cs typeface="Inter" pitchFamily="34" charset="-120"/>
-              </a:rPr>
-              <a:t>150 pooled connections</a:t>
+                  <a:srgbClr val="8FC7A2"/>
+                </a:solidFill>
+                <a:latin typeface="Inter" pitchFamily="34" charset="0"/>
+                <a:ea typeface="Inter" pitchFamily="34" charset="-122"/>
+                <a:cs typeface="Inter" pitchFamily="34" charset="-120"/>
+              </a:rPr>
+              <a:t>your box, your data</a:t>
             </a:r>
             <a:endParaRPr lang="en-US" sz="1000" dirty="0"/>
           </a:p>
@@ -4107,11 +4107,11 @@
         <p:spPr>
           <a:xfrm>
             <a:off x="6236208" y="1353312"/>
-            <a:ext cx="5193792" cy="4187952"/>
+            <a:ext cx="5193792" cy="4572000"/>
           </a:xfrm>
           <a:prstGeom prst="roundRect">
             <a:avLst>
-              <a:gd name="adj" fmla="val 1747"/>
+              <a:gd name="adj" fmla="val 1600"/>
             </a:avLst>
           </a:prstGeom>
           <a:solidFill>
@@ -4133,7 +4133,7 @@
         </p:nvSpPr>
         <p:spPr>
           <a:xfrm>
-            <a:off x="6473952" y="1572768"/>
+            <a:off x="6473952" y="1517904"/>
             <a:ext cx="4709160" cy="310896"/>
           </a:xfrm>
           <a:prstGeom prst="rect">
@@ -4160,7 +4160,7 @@
                 <a:ea typeface="Inter" pitchFamily="34" charset="-122"/>
                 <a:cs typeface="Inter" pitchFamily="34" charset="-120"/>
               </a:rPr>
-              <a:t>RDS is the industry-grade answer</a:t>
+              <a:t>Grows with you</a:t>
             </a:r>
             <a:endParaRPr lang="en-US" sz="1800" dirty="0"/>
           </a:p>
@@ -4168,101 +4168,23 @@
       </p:sp>
       <p:sp>
         <p:nvSpPr>
-          <p:cNvPr id="23" name="Text 21"/>
-          <p:cNvSpPr/>
-          <p:nvPr/>
-        </p:nvSpPr>
-        <p:spPr>
-          <a:xfrm>
-            <a:off x="6473952" y="1929384"/>
-            <a:ext cx="4645152" cy="274320"/>
-          </a:xfrm>
-          <a:prstGeom prst="rect">
-            <a:avLst/>
-          </a:prstGeom>
-          <a:noFill/>
-          <a:ln/>
-        </p:spPr>
-        <p:txBody>
-          <a:bodyPr wrap="square" lIns="0" tIns="0" rIns="0" bIns="0" rtlCol="0" anchor="ctr">
-            <a:normAutofit/>
-          </a:bodyPr>
-          <a:lstStyle/>
-          <a:p>
-            <a:pPr algn="l" indent="0" marL="0">
-              <a:buNone/>
-            </a:pPr>
-            <a:r>
-              <a:rPr lang="en-US" sz="1080" dirty="0">
-                <a:solidFill>
-                  <a:srgbClr val="A2AAA0"/>
-                </a:solidFill>
-                <a:latin typeface="JetBrains Mono" pitchFamily="34" charset="0"/>
-                <a:ea typeface="JetBrains Mono" pitchFamily="34" charset="-122"/>
-                <a:cs typeface="JetBrains Mono" pitchFamily="34" charset="-120"/>
-              </a:rPr>
-              <a:t>PITR · Multi-AZ failover · patching · monitoring · compliance</a:t>
-            </a:r>
-            <a:endParaRPr lang="en-US" sz="1080" dirty="0"/>
-          </a:p>
-        </p:txBody>
-      </p:sp>
-      <p:sp>
-        <p:nvSpPr>
-          <p:cNvPr id="24" name="Text 22"/>
-          <p:cNvSpPr/>
-          <p:nvPr/>
-        </p:nvSpPr>
-        <p:spPr>
-          <a:xfrm>
-            <a:off x="6473952" y="2350008"/>
-            <a:ext cx="4480560" cy="219456"/>
-          </a:xfrm>
-          <a:prstGeom prst="rect">
-            <a:avLst/>
-          </a:prstGeom>
-          <a:noFill/>
-          <a:ln/>
-        </p:spPr>
-        <p:txBody>
-          <a:bodyPr wrap="square" lIns="0" tIns="0" rIns="0" bIns="0" rtlCol="0" anchor="ctr">
-            <a:normAutofit/>
-          </a:bodyPr>
-          <a:lstStyle/>
-          <a:p>
-            <a:pPr algn="l" indent="0" marL="0">
-              <a:buNone/>
-            </a:pPr>
-            <a:r>
-              <a:rPr lang="en-US" sz="900" b="1" spc="100" kern="0" dirty="0">
-                <a:solidFill>
-                  <a:srgbClr val="A2AAA0"/>
-                </a:solidFill>
-                <a:latin typeface="Inter" pitchFamily="34" charset="0"/>
-                <a:ea typeface="Inter" pitchFamily="34" charset="-122"/>
-                <a:cs typeface="Inter" pitchFamily="34" charset="-120"/>
-              </a:rPr>
-              <a:t>50 LOW-TRAFFIC DATABASES / MONTH</a:t>
-            </a:r>
-            <a:endParaRPr lang="en-US" sz="900" dirty="0"/>
-          </a:p>
-        </p:txBody>
-      </p:sp>
-      <p:sp>
-        <p:nvSpPr>
-          <p:cNvPr id="25" name="Shape 23"/>
-          <p:cNvSpPr/>
-          <p:nvPr/>
-        </p:nvSpPr>
-        <p:spPr>
-          <a:xfrm>
-            <a:off x="6473952" y="2633472"/>
-            <a:ext cx="4636008" cy="0"/>
-          </a:xfrm>
-          <a:prstGeom prst="line">
-            <a:avLst/>
-          </a:prstGeom>
-          <a:noFill/>
+          <p:cNvPr id="23" name="Shape 21"/>
+          <p:cNvSpPr/>
+          <p:nvPr/>
+        </p:nvSpPr>
+        <p:spPr>
+          <a:xfrm>
+            <a:off x="6419088" y="1883664"/>
+            <a:ext cx="4828032" cy="402336"/>
+          </a:xfrm>
+          <a:prstGeom prst="roundRect">
+            <a:avLst>
+              <a:gd name="adj" fmla="val 18182"/>
+            </a:avLst>
+          </a:prstGeom>
+          <a:solidFill>
+            <a:srgbClr val="202622"/>
+          </a:solidFill>
           <a:ln w="12700">
             <a:solidFill>
               <a:srgbClr val="2A2F2C"/>
@@ -4273,311 +4195,17 @@
       </p:sp>
       <p:sp>
         <p:nvSpPr>
-          <p:cNvPr id="26" name="Text 24"/>
-          <p:cNvSpPr/>
-          <p:nvPr/>
-        </p:nvSpPr>
-        <p:spPr>
-          <a:xfrm>
-            <a:off x="6537960" y="2660904"/>
-            <a:ext cx="3520440" cy="384048"/>
-          </a:xfrm>
-          <a:prstGeom prst="rect">
-            <a:avLst/>
-          </a:prstGeom>
-          <a:noFill/>
-          <a:ln/>
-        </p:spPr>
-        <p:txBody>
-          <a:bodyPr wrap="square" lIns="0" tIns="0" rIns="0" bIns="0" rtlCol="0" anchor="ctr">
-            <a:normAutofit/>
-          </a:bodyPr>
-          <a:lstStyle/>
-          <a:p>
-            <a:pPr algn="l" indent="0" marL="0">
-              <a:buNone/>
-            </a:pPr>
-            <a:r>
-              <a:rPr lang="en-US" sz="1150" dirty="0">
-                <a:solidFill>
-                  <a:srgbClr val="ECEFE9"/>
-                </a:solidFill>
-                <a:latin typeface="Inter" pitchFamily="34" charset="0"/>
-                <a:ea typeface="Inter" pitchFamily="34" charset="-122"/>
-                <a:cs typeface="Inter" pitchFamily="34" charset="-120"/>
-              </a:rPr>
-              <a:t>RDS, one instance per project</a:t>
-            </a:r>
-            <a:endParaRPr lang="en-US" sz="1150" dirty="0"/>
-          </a:p>
-        </p:txBody>
-      </p:sp>
-      <p:sp>
-        <p:nvSpPr>
-          <p:cNvPr id="27" name="Text 25"/>
-          <p:cNvSpPr/>
-          <p:nvPr/>
-        </p:nvSpPr>
-        <p:spPr>
-          <a:xfrm>
-            <a:off x="10058400" y="2660904"/>
-            <a:ext cx="960120" cy="384048"/>
-          </a:xfrm>
-          <a:prstGeom prst="rect">
-            <a:avLst/>
-          </a:prstGeom>
-          <a:noFill/>
-          <a:ln/>
-        </p:spPr>
-        <p:txBody>
-          <a:bodyPr wrap="square" lIns="0" tIns="0" rIns="0" bIns="0" rtlCol="0" anchor="ctr">
-            <a:normAutofit/>
-          </a:bodyPr>
-          <a:lstStyle/>
-          <a:p>
-            <a:pPr algn="r" indent="0" marL="0">
-              <a:buNone/>
-            </a:pPr>
-            <a:r>
-              <a:rPr lang="en-US" sz="1300" b="1" dirty="0">
-                <a:solidFill>
-                  <a:srgbClr val="ECEFE9"/>
-                </a:solidFill>
-                <a:latin typeface="JetBrains Mono" pitchFamily="34" charset="0"/>
-                <a:ea typeface="JetBrains Mono" pitchFamily="34" charset="-122"/>
-                <a:cs typeface="JetBrains Mono" pitchFamily="34" charset="-120"/>
-              </a:rPr>
-              <a:t>$699</a:t>
-            </a:r>
-            <a:endParaRPr lang="en-US" sz="1300" dirty="0"/>
-          </a:p>
-        </p:txBody>
-      </p:sp>
-      <p:sp>
-        <p:nvSpPr>
-          <p:cNvPr id="28" name="Shape 26"/>
-          <p:cNvSpPr/>
-          <p:nvPr/>
-        </p:nvSpPr>
-        <p:spPr>
-          <a:xfrm>
-            <a:off x="6473952" y="3163824"/>
-            <a:ext cx="4636008" cy="0"/>
-          </a:xfrm>
-          <a:prstGeom prst="line">
-            <a:avLst/>
-          </a:prstGeom>
-          <a:noFill/>
-          <a:ln w="12700">
-            <a:solidFill>
-              <a:srgbClr val="2A2F2C"/>
-            </a:solidFill>
-            <a:prstDash val="solid"/>
-          </a:ln>
-        </p:spPr>
-      </p:sp>
-      <p:sp>
-        <p:nvSpPr>
-          <p:cNvPr id="29" name="Text 27"/>
-          <p:cNvSpPr/>
-          <p:nvPr/>
-        </p:nvSpPr>
-        <p:spPr>
-          <a:xfrm>
-            <a:off x="6537960" y="3191256"/>
-            <a:ext cx="3520440" cy="384048"/>
-          </a:xfrm>
-          <a:prstGeom prst="rect">
-            <a:avLst/>
-          </a:prstGeom>
-          <a:noFill/>
-          <a:ln/>
-        </p:spPr>
-        <p:txBody>
-          <a:bodyPr wrap="square" lIns="0" tIns="0" rIns="0" bIns="0" rtlCol="0" anchor="ctr">
-            <a:normAutofit/>
-          </a:bodyPr>
-          <a:lstStyle/>
-          <a:p>
-            <a:pPr algn="l" indent="0" marL="0">
-              <a:buNone/>
-            </a:pPr>
-            <a:r>
-              <a:rPr lang="en-US" sz="1150" dirty="0">
-                <a:solidFill>
-                  <a:srgbClr val="ECEFE9"/>
-                </a:solidFill>
-                <a:latin typeface="Inter" pitchFamily="34" charset="0"/>
-                <a:ea typeface="Inter" pitchFamily="34" charset="-122"/>
-                <a:cs typeface="Inter" pitchFamily="34" charset="-120"/>
-              </a:rPr>
-              <a:t>RDS, one shared db.t4g.small</a:t>
-            </a:r>
-            <a:endParaRPr lang="en-US" sz="1150" dirty="0"/>
-          </a:p>
-        </p:txBody>
-      </p:sp>
-      <p:sp>
-        <p:nvSpPr>
-          <p:cNvPr id="30" name="Text 28"/>
-          <p:cNvSpPr/>
-          <p:nvPr/>
-        </p:nvSpPr>
-        <p:spPr>
-          <a:xfrm>
-            <a:off x="10058400" y="3191256"/>
-            <a:ext cx="960120" cy="384048"/>
-          </a:xfrm>
-          <a:prstGeom prst="rect">
-            <a:avLst/>
-          </a:prstGeom>
-          <a:noFill/>
-          <a:ln/>
-        </p:spPr>
-        <p:txBody>
-          <a:bodyPr wrap="square" lIns="0" tIns="0" rIns="0" bIns="0" rtlCol="0" anchor="ctr">
-            <a:normAutofit/>
-          </a:bodyPr>
-          <a:lstStyle/>
-          <a:p>
-            <a:pPr algn="r" indent="0" marL="0">
-              <a:buNone/>
-            </a:pPr>
-            <a:r>
-              <a:rPr lang="en-US" sz="1300" b="1" dirty="0">
-                <a:solidFill>
-                  <a:srgbClr val="ECEFE9"/>
-                </a:solidFill>
-                <a:latin typeface="JetBrains Mono" pitchFamily="34" charset="0"/>
-                <a:ea typeface="JetBrains Mono" pitchFamily="34" charset="-122"/>
-                <a:cs typeface="JetBrains Mono" pitchFamily="34" charset="-120"/>
-              </a:rPr>
-              <a:t>$25.66</a:t>
-            </a:r>
-            <a:endParaRPr lang="en-US" sz="1300" dirty="0"/>
-          </a:p>
-        </p:txBody>
-      </p:sp>
-      <p:sp>
-        <p:nvSpPr>
-          <p:cNvPr id="31" name="Shape 29"/>
-          <p:cNvSpPr/>
-          <p:nvPr/>
-        </p:nvSpPr>
-        <p:spPr>
-          <a:xfrm>
-            <a:off x="6473952" y="3694176"/>
-            <a:ext cx="4636008" cy="0"/>
-          </a:xfrm>
-          <a:prstGeom prst="line">
-            <a:avLst/>
-          </a:prstGeom>
-          <a:noFill/>
-          <a:ln w="12700">
-            <a:solidFill>
-              <a:srgbClr val="2A2F2C"/>
-            </a:solidFill>
-            <a:prstDash val="solid"/>
-          </a:ln>
-        </p:spPr>
-      </p:sp>
-      <p:sp>
-        <p:nvSpPr>
-          <p:cNvPr id="32" name="Text 30"/>
-          <p:cNvSpPr/>
-          <p:nvPr/>
-        </p:nvSpPr>
-        <p:spPr>
-          <a:xfrm>
-            <a:off x="6537960" y="3721608"/>
-            <a:ext cx="3520440" cy="384048"/>
-          </a:xfrm>
-          <a:prstGeom prst="rect">
-            <a:avLst/>
-          </a:prstGeom>
-          <a:noFill/>
-          <a:ln/>
-        </p:spPr>
-        <p:txBody>
-          <a:bodyPr wrap="square" lIns="0" tIns="0" rIns="0" bIns="0" rtlCol="0" anchor="ctr">
-            <a:normAutofit/>
-          </a:bodyPr>
-          <a:lstStyle/>
-          <a:p>
-            <a:pPr algn="l" indent="0" marL="0">
-              <a:buNone/>
-            </a:pPr>
-            <a:r>
-              <a:rPr lang="en-US" sz="1150" dirty="0">
-                <a:solidFill>
-                  <a:srgbClr val="ECEFE9"/>
-                </a:solidFill>
-                <a:latin typeface="Inter" pitchFamily="34" charset="0"/>
-                <a:ea typeface="Inter" pitchFamily="34" charset="-122"/>
-                <a:cs typeface="Inter" pitchFamily="34" charset="-120"/>
-              </a:rPr>
-              <a:t>Lightsail managed PostgreSQL 2 GB</a:t>
-            </a:r>
-            <a:endParaRPr lang="en-US" sz="1150" dirty="0"/>
-          </a:p>
-        </p:txBody>
-      </p:sp>
-      <p:sp>
-        <p:nvSpPr>
-          <p:cNvPr id="33" name="Text 31"/>
-          <p:cNvSpPr/>
-          <p:nvPr/>
-        </p:nvSpPr>
-        <p:spPr>
-          <a:xfrm>
-            <a:off x="10058400" y="3721608"/>
-            <a:ext cx="960120" cy="384048"/>
-          </a:xfrm>
-          <a:prstGeom prst="rect">
-            <a:avLst/>
-          </a:prstGeom>
-          <a:noFill/>
-          <a:ln/>
-        </p:spPr>
-        <p:txBody>
-          <a:bodyPr wrap="square" lIns="0" tIns="0" rIns="0" bIns="0" rtlCol="0" anchor="ctr">
-            <a:normAutofit/>
-          </a:bodyPr>
-          <a:lstStyle/>
-          <a:p>
-            <a:pPr algn="r" indent="0" marL="0">
-              <a:buNone/>
-            </a:pPr>
-            <a:r>
-              <a:rPr lang="en-US" sz="1300" b="1" dirty="0">
-                <a:solidFill>
-                  <a:srgbClr val="ECEFE9"/>
-                </a:solidFill>
-                <a:latin typeface="JetBrains Mono" pitchFamily="34" charset="0"/>
-                <a:ea typeface="JetBrains Mono" pitchFamily="34" charset="-122"/>
-                <a:cs typeface="JetBrains Mono" pitchFamily="34" charset="-120"/>
-              </a:rPr>
-              <a:t>$30</a:t>
-            </a:r>
-            <a:endParaRPr lang="en-US" sz="1300" dirty="0"/>
-          </a:p>
-        </p:txBody>
-      </p:sp>
-      <p:sp>
-        <p:nvSpPr>
-          <p:cNvPr id="34" name="Shape 32"/>
-          <p:cNvSpPr/>
-          <p:nvPr/>
-        </p:nvSpPr>
-        <p:spPr>
-          <a:xfrm>
-            <a:off x="6419088" y="4233672"/>
-            <a:ext cx="4800600" cy="475488"/>
-          </a:xfrm>
-          <a:prstGeom prst="roundRect">
-            <a:avLst>
-              <a:gd name="adj" fmla="val 15385"/>
-            </a:avLst>
+          <p:cNvPr id="24" name="Shape 22"/>
+          <p:cNvSpPr/>
+          <p:nvPr/>
+        </p:nvSpPr>
+        <p:spPr>
+          <a:xfrm>
+            <a:off x="6510528" y="1965960"/>
+            <a:ext cx="237744" cy="237744"/>
+          </a:xfrm>
+          <a:prstGeom prst="ellipse">
+            <a:avLst/>
           </a:prstGeom>
           <a:solidFill>
             <a:srgbClr val="202E25"/>
@@ -4592,14 +4220,55 @@
       </p:sp>
       <p:sp>
         <p:nvSpPr>
-          <p:cNvPr id="35" name="Text 33"/>
-          <p:cNvSpPr/>
-          <p:nvPr/>
-        </p:nvSpPr>
-        <p:spPr>
-          <a:xfrm>
-            <a:off x="6537960" y="4251960"/>
-            <a:ext cx="3520440" cy="384048"/>
+          <p:cNvPr id="25" name="Text 23"/>
+          <p:cNvSpPr/>
+          <p:nvPr/>
+        </p:nvSpPr>
+        <p:spPr>
+          <a:xfrm>
+            <a:off x="6510528" y="1965960"/>
+            <a:ext cx="237744" cy="237744"/>
+          </a:xfrm>
+          <a:prstGeom prst="rect">
+            <a:avLst/>
+          </a:prstGeom>
+          <a:noFill/>
+          <a:ln/>
+        </p:spPr>
+        <p:txBody>
+          <a:bodyPr wrap="square" lIns="0" tIns="0" rIns="0" bIns="0" rtlCol="0" anchor="ctr">
+            <a:normAutofit/>
+          </a:bodyPr>
+          <a:lstStyle/>
+          <a:p>
+            <a:pPr algn="ctr" indent="0" marL="0">
+              <a:buNone/>
+            </a:pPr>
+            <a:r>
+              <a:rPr lang="en-US" sz="950" b="1" dirty="0">
+                <a:solidFill>
+                  <a:srgbClr val="8FC7A2"/>
+                </a:solidFill>
+                <a:latin typeface="Inter" pitchFamily="34" charset="0"/>
+                <a:ea typeface="Inter" pitchFamily="34" charset="-122"/>
+                <a:cs typeface="Inter" pitchFamily="34" charset="-120"/>
+              </a:rPr>
+              <a:t>1</a:t>
+            </a:r>
+            <a:endParaRPr lang="en-US" sz="950" dirty="0"/>
+          </a:p>
+        </p:txBody>
+      </p:sp>
+      <p:sp>
+        <p:nvSpPr>
+          <p:cNvPr id="26" name="Text 24"/>
+          <p:cNvSpPr/>
+          <p:nvPr/>
+        </p:nvSpPr>
+        <p:spPr>
+          <a:xfrm>
+            <a:off x="6821424" y="1901952"/>
+            <a:ext cx="3108960" cy="365760"/>
           </a:xfrm>
           <a:prstGeom prst="rect">
             <a:avLst/>
@@ -4617,30 +4286,30 @@
               <a:buNone/>
             </a:pPr>
             <a:r>
-              <a:rPr lang="en-US" sz="1150" dirty="0">
-                <a:solidFill>
-                  <a:srgbClr val="8FC7A2"/>
-                </a:solidFill>
-                <a:latin typeface="Inter" pitchFamily="34" charset="0"/>
-                <a:ea typeface="Inter" pitchFamily="34" charset="-122"/>
-                <a:cs typeface="Inter" pitchFamily="34" charset="-120"/>
-              </a:rPr>
-              <a:t>Pgfy on Lightsail + S3</a:t>
-            </a:r>
-            <a:endParaRPr lang="en-US" sz="1150" dirty="0"/>
-          </a:p>
-        </p:txBody>
-      </p:sp>
-      <p:sp>
-        <p:nvSpPr>
-          <p:cNvPr id="36" name="Text 34"/>
-          <p:cNvSpPr/>
-          <p:nvPr/>
-        </p:nvSpPr>
-        <p:spPr>
-          <a:xfrm>
-            <a:off x="10058400" y="4251960"/>
-            <a:ext cx="960120" cy="384048"/>
+              <a:rPr lang="en-US" sz="1020" dirty="0">
+                <a:solidFill>
+                  <a:srgbClr val="ECEFE9"/>
+                </a:solidFill>
+                <a:latin typeface="Inter" pitchFamily="34" charset="0"/>
+                <a:ea typeface="Inter" pitchFamily="34" charset="-122"/>
+                <a:cs typeface="Inter" pitchFamily="34" charset="-120"/>
+              </a:rPr>
+              <a:t>Many small apps on one Pgfy box</a:t>
+            </a:r>
+            <a:endParaRPr lang="en-US" sz="1020" dirty="0"/>
+          </a:p>
+        </p:txBody>
+      </p:sp>
+      <p:sp>
+        <p:nvSpPr>
+          <p:cNvPr id="27" name="Text 25"/>
+          <p:cNvSpPr/>
+          <p:nvPr/>
+        </p:nvSpPr>
+        <p:spPr>
+          <a:xfrm>
+            <a:off x="9921240" y="1901952"/>
+            <a:ext cx="1261872" cy="365760"/>
           </a:xfrm>
           <a:prstGeom prst="rect">
             <a:avLst/>
@@ -4658,7 +4327,7 @@
               <a:buNone/>
             </a:pPr>
             <a:r>
-              <a:rPr lang="en-US" sz="1300" b="1" dirty="0">
+              <a:rPr lang="en-US" sz="880" b="1" dirty="0">
                 <a:solidFill>
                   <a:srgbClr val="8FC7A2"/>
                 </a:solidFill>
@@ -4666,6 +4335,855 @@
                 <a:ea typeface="JetBrains Mono" pitchFamily="34" charset="-122"/>
                 <a:cs typeface="JetBrains Mono" pitchFamily="34" charset="-120"/>
               </a:rPr>
+              <a:t>$12 · 2 GB</a:t>
+            </a:r>
+            <a:endParaRPr lang="en-US" sz="880" dirty="0"/>
+          </a:p>
+        </p:txBody>
+      </p:sp>
+      <p:sp>
+        <p:nvSpPr>
+          <p:cNvPr id="28" name="Shape 26"/>
+          <p:cNvSpPr/>
+          <p:nvPr/>
+        </p:nvSpPr>
+        <p:spPr>
+          <a:xfrm>
+            <a:off x="6419088" y="2340864"/>
+            <a:ext cx="4828032" cy="402336"/>
+          </a:xfrm>
+          <a:prstGeom prst="roundRect">
+            <a:avLst>
+              <a:gd name="adj" fmla="val 18182"/>
+            </a:avLst>
+          </a:prstGeom>
+          <a:solidFill>
+            <a:srgbClr val="202622"/>
+          </a:solidFill>
+          <a:ln w="12700">
+            <a:solidFill>
+              <a:srgbClr val="2A2F2C"/>
+            </a:solidFill>
+            <a:prstDash val="solid"/>
+          </a:ln>
+        </p:spPr>
+      </p:sp>
+      <p:sp>
+        <p:nvSpPr>
+          <p:cNvPr id="29" name="Shape 27"/>
+          <p:cNvSpPr/>
+          <p:nvPr/>
+        </p:nvSpPr>
+        <p:spPr>
+          <a:xfrm>
+            <a:off x="6510528" y="2423160"/>
+            <a:ext cx="237744" cy="237744"/>
+          </a:xfrm>
+          <a:prstGeom prst="ellipse">
+            <a:avLst/>
+          </a:prstGeom>
+          <a:solidFill>
+            <a:srgbClr val="202E25"/>
+          </a:solidFill>
+          <a:ln w="12700">
+            <a:solidFill>
+              <a:srgbClr val="202E25"/>
+            </a:solidFill>
+            <a:prstDash val="solid"/>
+          </a:ln>
+        </p:spPr>
+      </p:sp>
+      <p:sp>
+        <p:nvSpPr>
+          <p:cNvPr id="30" name="Text 28"/>
+          <p:cNvSpPr/>
+          <p:nvPr/>
+        </p:nvSpPr>
+        <p:spPr>
+          <a:xfrm>
+            <a:off x="6510528" y="2423160"/>
+            <a:ext cx="237744" cy="237744"/>
+          </a:xfrm>
+          <a:prstGeom prst="rect">
+            <a:avLst/>
+          </a:prstGeom>
+          <a:noFill/>
+          <a:ln/>
+        </p:spPr>
+        <p:txBody>
+          <a:bodyPr wrap="square" lIns="0" tIns="0" rIns="0" bIns="0" rtlCol="0" anchor="ctr">
+            <a:normAutofit/>
+          </a:bodyPr>
+          <a:lstStyle/>
+          <a:p>
+            <a:pPr algn="ctr" indent="0" marL="0">
+              <a:buNone/>
+            </a:pPr>
+            <a:r>
+              <a:rPr lang="en-US" sz="950" b="1" dirty="0">
+                <a:solidFill>
+                  <a:srgbClr val="8FC7A2"/>
+                </a:solidFill>
+                <a:latin typeface="Inter" pitchFamily="34" charset="0"/>
+                <a:ea typeface="Inter" pitchFamily="34" charset="-122"/>
+                <a:cs typeface="Inter" pitchFamily="34" charset="-120"/>
+              </a:rPr>
+              <a:t>2</a:t>
+            </a:r>
+            <a:endParaRPr lang="en-US" sz="950" dirty="0"/>
+          </a:p>
+        </p:txBody>
+      </p:sp>
+      <p:sp>
+        <p:nvSpPr>
+          <p:cNvPr id="31" name="Text 29"/>
+          <p:cNvSpPr/>
+          <p:nvPr/>
+        </p:nvSpPr>
+        <p:spPr>
+          <a:xfrm>
+            <a:off x="6821424" y="2359152"/>
+            <a:ext cx="3108960" cy="365760"/>
+          </a:xfrm>
+          <a:prstGeom prst="rect">
+            <a:avLst/>
+          </a:prstGeom>
+          <a:noFill/>
+          <a:ln/>
+        </p:spPr>
+        <p:txBody>
+          <a:bodyPr wrap="square" lIns="0" tIns="0" rIns="0" bIns="0" rtlCol="0" anchor="ctr">
+            <a:normAutofit/>
+          </a:bodyPr>
+          <a:lstStyle/>
+          <a:p>
+            <a:pPr algn="l" indent="0" marL="0">
+              <a:buNone/>
+            </a:pPr>
+            <a:r>
+              <a:rPr lang="en-US" sz="1020" dirty="0">
+                <a:solidFill>
+                  <a:srgbClr val="ECEFE9"/>
+                </a:solidFill>
+                <a:latin typeface="Inter" pitchFamily="34" charset="0"/>
+                <a:ea typeface="Inter" pitchFamily="34" charset="-122"/>
+                <a:cs typeface="Inter" pitchFamily="34" charset="-120"/>
+              </a:rPr>
+              <a:t>One app takes off: its own Pgfy box, restored in under 5 min</a:t>
+            </a:r>
+            <a:endParaRPr lang="en-US" sz="1020" dirty="0"/>
+          </a:p>
+        </p:txBody>
+      </p:sp>
+      <p:sp>
+        <p:nvSpPr>
+          <p:cNvPr id="32" name="Text 30"/>
+          <p:cNvSpPr/>
+          <p:nvPr/>
+        </p:nvSpPr>
+        <p:spPr>
+          <a:xfrm>
+            <a:off x="9921240" y="2359152"/>
+            <a:ext cx="1261872" cy="365760"/>
+          </a:xfrm>
+          <a:prstGeom prst="rect">
+            <a:avLst/>
+          </a:prstGeom>
+          <a:noFill/>
+          <a:ln/>
+        </p:spPr>
+        <p:txBody>
+          <a:bodyPr wrap="square" lIns="0" tIns="0" rIns="0" bIns="0" rtlCol="0" anchor="ctr">
+            <a:normAutofit/>
+          </a:bodyPr>
+          <a:lstStyle/>
+          <a:p>
+            <a:pPr algn="r" indent="0" marL="0">
+              <a:buNone/>
+            </a:pPr>
+            <a:r>
+              <a:rPr lang="en-US" sz="880" b="1" dirty="0">
+                <a:solidFill>
+                  <a:srgbClr val="8FC7A2"/>
+                </a:solidFill>
+                <a:latin typeface="JetBrains Mono" pitchFamily="34" charset="0"/>
+                <a:ea typeface="JetBrains Mono" pitchFamily="34" charset="-122"/>
+                <a:cs typeface="JetBrains Mono" pitchFamily="34" charset="-120"/>
+              </a:rPr>
+              <a:t>$24 · 4 GB</a:t>
+            </a:r>
+            <a:endParaRPr lang="en-US" sz="880" dirty="0"/>
+          </a:p>
+          <a:p>
+            <a:pPr algn="r" indent="0" marL="0">
+              <a:buNone/>
+            </a:pPr>
+            <a:r>
+              <a:rPr lang="en-US" sz="880" b="1" dirty="0">
+                <a:solidFill>
+                  <a:srgbClr val="8FC7A2"/>
+                </a:solidFill>
+                <a:latin typeface="JetBrains Mono" pitchFamily="34" charset="0"/>
+                <a:ea typeface="JetBrains Mono" pitchFamily="34" charset="-122"/>
+                <a:cs typeface="JetBrains Mono" pitchFamily="34" charset="-120"/>
+              </a:rPr>
+              <a:t>$44 · 8 GB</a:t>
+            </a:r>
+            <a:endParaRPr lang="en-US" sz="880" dirty="0"/>
+          </a:p>
+        </p:txBody>
+      </p:sp>
+      <p:sp>
+        <p:nvSpPr>
+          <p:cNvPr id="33" name="Shape 31"/>
+          <p:cNvSpPr/>
+          <p:nvPr/>
+        </p:nvSpPr>
+        <p:spPr>
+          <a:xfrm>
+            <a:off x="6419088" y="2798064"/>
+            <a:ext cx="4828032" cy="402336"/>
+          </a:xfrm>
+          <a:prstGeom prst="roundRect">
+            <a:avLst>
+              <a:gd name="adj" fmla="val 18182"/>
+            </a:avLst>
+          </a:prstGeom>
+          <a:solidFill>
+            <a:srgbClr val="202622"/>
+          </a:solidFill>
+          <a:ln w="12700">
+            <a:solidFill>
+              <a:srgbClr val="2A2F2C"/>
+            </a:solidFill>
+            <a:prstDash val="solid"/>
+          </a:ln>
+        </p:spPr>
+      </p:sp>
+      <p:sp>
+        <p:nvSpPr>
+          <p:cNvPr id="34" name="Shape 32"/>
+          <p:cNvSpPr/>
+          <p:nvPr/>
+        </p:nvSpPr>
+        <p:spPr>
+          <a:xfrm>
+            <a:off x="6510528" y="2880360"/>
+            <a:ext cx="237744" cy="237744"/>
+          </a:xfrm>
+          <a:prstGeom prst="ellipse">
+            <a:avLst/>
+          </a:prstGeom>
+          <a:solidFill>
+            <a:srgbClr val="202E25"/>
+          </a:solidFill>
+          <a:ln w="12700">
+            <a:solidFill>
+              <a:srgbClr val="202E25"/>
+            </a:solidFill>
+            <a:prstDash val="solid"/>
+          </a:ln>
+        </p:spPr>
+      </p:sp>
+      <p:sp>
+        <p:nvSpPr>
+          <p:cNvPr id="35" name="Text 33"/>
+          <p:cNvSpPr/>
+          <p:nvPr/>
+        </p:nvSpPr>
+        <p:spPr>
+          <a:xfrm>
+            <a:off x="6510528" y="2880360"/>
+            <a:ext cx="237744" cy="237744"/>
+          </a:xfrm>
+          <a:prstGeom prst="rect">
+            <a:avLst/>
+          </a:prstGeom>
+          <a:noFill/>
+          <a:ln/>
+        </p:spPr>
+        <p:txBody>
+          <a:bodyPr wrap="square" lIns="0" tIns="0" rIns="0" bIns="0" rtlCol="0" anchor="ctr">
+            <a:normAutofit/>
+          </a:bodyPr>
+          <a:lstStyle/>
+          <a:p>
+            <a:pPr algn="ctr" indent="0" marL="0">
+              <a:buNone/>
+            </a:pPr>
+            <a:r>
+              <a:rPr lang="en-US" sz="950" b="1" dirty="0">
+                <a:solidFill>
+                  <a:srgbClr val="8FC7A2"/>
+                </a:solidFill>
+                <a:latin typeface="Inter" pitchFamily="34" charset="0"/>
+                <a:ea typeface="Inter" pitchFamily="34" charset="-122"/>
+                <a:cs typeface="Inter" pitchFamily="34" charset="-120"/>
+              </a:rPr>
+              <a:t>3</a:t>
+            </a:r>
+            <a:endParaRPr lang="en-US" sz="950" dirty="0"/>
+          </a:p>
+        </p:txBody>
+      </p:sp>
+      <p:sp>
+        <p:nvSpPr>
+          <p:cNvPr id="36" name="Text 34"/>
+          <p:cNvSpPr/>
+          <p:nvPr/>
+        </p:nvSpPr>
+        <p:spPr>
+          <a:xfrm>
+            <a:off x="6821424" y="2816352"/>
+            <a:ext cx="3108960" cy="365760"/>
+          </a:xfrm>
+          <a:prstGeom prst="rect">
+            <a:avLst/>
+          </a:prstGeom>
+          <a:noFill/>
+          <a:ln/>
+        </p:spPr>
+        <p:txBody>
+          <a:bodyPr wrap="square" lIns="0" tIns="0" rIns="0" bIns="0" rtlCol="0" anchor="ctr">
+            <a:normAutofit/>
+          </a:bodyPr>
+          <a:lstStyle/>
+          <a:p>
+            <a:pPr algn="l" indent="0" marL="0">
+              <a:buNone/>
+            </a:pPr>
+            <a:r>
+              <a:rPr lang="en-US" sz="1020" dirty="0">
+                <a:solidFill>
+                  <a:srgbClr val="ECEFE9"/>
+                </a:solidFill>
+                <a:latin typeface="Inter" pitchFamily="34" charset="0"/>
+                <a:ea typeface="Inter" pitchFamily="34" charset="-122"/>
+                <a:cs typeface="Inter" pitchFamily="34" charset="-120"/>
+              </a:rPr>
+              <a:t>Want managed HA and PITR? pg_restore the archive into RDS</a:t>
+            </a:r>
+            <a:endParaRPr lang="en-US" sz="1020" dirty="0"/>
+          </a:p>
+        </p:txBody>
+      </p:sp>
+      <p:sp>
+        <p:nvSpPr>
+          <p:cNvPr id="37" name="Text 35"/>
+          <p:cNvSpPr/>
+          <p:nvPr/>
+        </p:nvSpPr>
+        <p:spPr>
+          <a:xfrm>
+            <a:off x="9921240" y="2816352"/>
+            <a:ext cx="1261872" cy="365760"/>
+          </a:xfrm>
+          <a:prstGeom prst="rect">
+            <a:avLst/>
+          </a:prstGeom>
+          <a:noFill/>
+          <a:ln/>
+        </p:spPr>
+        <p:txBody>
+          <a:bodyPr wrap="square" lIns="0" tIns="0" rIns="0" bIns="0" rtlCol="0" anchor="ctr">
+            <a:normAutofit/>
+          </a:bodyPr>
+          <a:lstStyle/>
+          <a:p>
+            <a:pPr algn="r" indent="0" marL="0">
+              <a:buNone/>
+            </a:pPr>
+            <a:r>
+              <a:rPr lang="en-US" sz="880" b="1" dirty="0">
+                <a:solidFill>
+                  <a:srgbClr val="8FC7A2"/>
+                </a:solidFill>
+                <a:latin typeface="JetBrains Mono" pitchFamily="34" charset="0"/>
+                <a:ea typeface="JetBrains Mono" pitchFamily="34" charset="-122"/>
+                <a:cs typeface="JetBrains Mono" pitchFamily="34" charset="-120"/>
+              </a:rPr>
+              <a:t>$116 · 8 GB</a:t>
+            </a:r>
+            <a:endParaRPr lang="en-US" sz="880" dirty="0"/>
+          </a:p>
+          <a:p>
+            <a:pPr algn="r" indent="0" marL="0">
+              <a:buNone/>
+            </a:pPr>
+            <a:r>
+              <a:rPr lang="en-US" sz="880" b="1" dirty="0">
+                <a:solidFill>
+                  <a:srgbClr val="8FC7A2"/>
+                </a:solidFill>
+                <a:latin typeface="JetBrains Mono" pitchFamily="34" charset="0"/>
+                <a:ea typeface="JetBrains Mono" pitchFamily="34" charset="-122"/>
+                <a:cs typeface="JetBrains Mono" pitchFamily="34" charset="-120"/>
+              </a:rPr>
+              <a:t>db.m6g.large</a:t>
+            </a:r>
+            <a:endParaRPr lang="en-US" sz="880" dirty="0"/>
+          </a:p>
+        </p:txBody>
+      </p:sp>
+      <p:sp>
+        <p:nvSpPr>
+          <p:cNvPr id="38" name="Text 36"/>
+          <p:cNvSpPr/>
+          <p:nvPr/>
+        </p:nvSpPr>
+        <p:spPr>
+          <a:xfrm>
+            <a:off x="6473952" y="3310128"/>
+            <a:ext cx="4480560" cy="219456"/>
+          </a:xfrm>
+          <a:prstGeom prst="rect">
+            <a:avLst/>
+          </a:prstGeom>
+          <a:noFill/>
+          <a:ln/>
+        </p:spPr>
+        <p:txBody>
+          <a:bodyPr wrap="square" lIns="0" tIns="0" rIns="0" bIns="0" rtlCol="0" anchor="ctr">
+            <a:normAutofit/>
+          </a:bodyPr>
+          <a:lstStyle/>
+          <a:p>
+            <a:pPr algn="l" indent="0" marL="0">
+              <a:buNone/>
+            </a:pPr>
+            <a:r>
+              <a:rPr lang="en-US" sz="900" b="1" spc="100" kern="0" dirty="0">
+                <a:solidFill>
+                  <a:srgbClr val="A2AAA0"/>
+                </a:solidFill>
+                <a:latin typeface="Inter" pitchFamily="34" charset="0"/>
+                <a:ea typeface="Inter" pitchFamily="34" charset="-122"/>
+                <a:cs typeface="Inter" pitchFamily="34" charset="-120"/>
+              </a:rPr>
+              <a:t>50 LOW-TRAFFIC DATABASES / MONTH</a:t>
+            </a:r>
+            <a:endParaRPr lang="en-US" sz="900" dirty="0"/>
+          </a:p>
+        </p:txBody>
+      </p:sp>
+      <p:sp>
+        <p:nvSpPr>
+          <p:cNvPr id="39" name="Shape 37"/>
+          <p:cNvSpPr/>
+          <p:nvPr/>
+        </p:nvSpPr>
+        <p:spPr>
+          <a:xfrm>
+            <a:off x="6473952" y="3557016"/>
+            <a:ext cx="4636008" cy="0"/>
+          </a:xfrm>
+          <a:prstGeom prst="line">
+            <a:avLst/>
+          </a:prstGeom>
+          <a:noFill/>
+          <a:ln w="12700">
+            <a:solidFill>
+              <a:srgbClr val="2A2F2C"/>
+            </a:solidFill>
+            <a:prstDash val="solid"/>
+          </a:ln>
+        </p:spPr>
+      </p:sp>
+      <p:sp>
+        <p:nvSpPr>
+          <p:cNvPr id="40" name="Text 38"/>
+          <p:cNvSpPr/>
+          <p:nvPr/>
+        </p:nvSpPr>
+        <p:spPr>
+          <a:xfrm>
+            <a:off x="6537960" y="3584448"/>
+            <a:ext cx="3520440" cy="384048"/>
+          </a:xfrm>
+          <a:prstGeom prst="rect">
+            <a:avLst/>
+          </a:prstGeom>
+          <a:noFill/>
+          <a:ln/>
+        </p:spPr>
+        <p:txBody>
+          <a:bodyPr wrap="square" lIns="0" tIns="0" rIns="0" bIns="0" rtlCol="0" anchor="ctr">
+            <a:normAutofit/>
+          </a:bodyPr>
+          <a:lstStyle/>
+          <a:p>
+            <a:pPr algn="l" indent="0" marL="0">
+              <a:buNone/>
+            </a:pPr>
+            <a:r>
+              <a:rPr lang="en-US" sz="1150" dirty="0">
+                <a:solidFill>
+                  <a:srgbClr val="ECEFE9"/>
+                </a:solidFill>
+                <a:latin typeface="Inter" pitchFamily="34" charset="0"/>
+                <a:ea typeface="Inter" pitchFamily="34" charset="-122"/>
+                <a:cs typeface="Inter" pitchFamily="34" charset="-120"/>
+              </a:rPr>
+              <a:t>RDS, one instance per project</a:t>
+            </a:r>
+            <a:endParaRPr lang="en-US" sz="1150" dirty="0"/>
+          </a:p>
+        </p:txBody>
+      </p:sp>
+      <p:sp>
+        <p:nvSpPr>
+          <p:cNvPr id="41" name="Text 39"/>
+          <p:cNvSpPr/>
+          <p:nvPr/>
+        </p:nvSpPr>
+        <p:spPr>
+          <a:xfrm>
+            <a:off x="10058400" y="3584448"/>
+            <a:ext cx="960120" cy="384048"/>
+          </a:xfrm>
+          <a:prstGeom prst="rect">
+            <a:avLst/>
+          </a:prstGeom>
+          <a:noFill/>
+          <a:ln/>
+        </p:spPr>
+        <p:txBody>
+          <a:bodyPr wrap="square" lIns="0" tIns="0" rIns="0" bIns="0" rtlCol="0" anchor="ctr">
+            <a:normAutofit/>
+          </a:bodyPr>
+          <a:lstStyle/>
+          <a:p>
+            <a:pPr algn="r" indent="0" marL="0">
+              <a:buNone/>
+            </a:pPr>
+            <a:r>
+              <a:rPr lang="en-US" sz="1300" b="1" dirty="0">
+                <a:solidFill>
+                  <a:srgbClr val="ECEFE9"/>
+                </a:solidFill>
+                <a:latin typeface="JetBrains Mono" pitchFamily="34" charset="0"/>
+                <a:ea typeface="JetBrains Mono" pitchFamily="34" charset="-122"/>
+                <a:cs typeface="JetBrains Mono" pitchFamily="34" charset="-120"/>
+              </a:rPr>
+              <a:t>$699</a:t>
+            </a:r>
+            <a:endParaRPr lang="en-US" sz="1300" dirty="0"/>
+          </a:p>
+        </p:txBody>
+      </p:sp>
+      <p:sp>
+        <p:nvSpPr>
+          <p:cNvPr id="42" name="Shape 40"/>
+          <p:cNvSpPr/>
+          <p:nvPr/>
+        </p:nvSpPr>
+        <p:spPr>
+          <a:xfrm>
+            <a:off x="6473952" y="4059936"/>
+            <a:ext cx="4636008" cy="0"/>
+          </a:xfrm>
+          <a:prstGeom prst="line">
+            <a:avLst/>
+          </a:prstGeom>
+          <a:noFill/>
+          <a:ln w="12700">
+            <a:solidFill>
+              <a:srgbClr val="2A2F2C"/>
+            </a:solidFill>
+            <a:prstDash val="solid"/>
+          </a:ln>
+        </p:spPr>
+      </p:sp>
+      <p:sp>
+        <p:nvSpPr>
+          <p:cNvPr id="43" name="Text 41"/>
+          <p:cNvSpPr/>
+          <p:nvPr/>
+        </p:nvSpPr>
+        <p:spPr>
+          <a:xfrm>
+            <a:off x="6537960" y="4087368"/>
+            <a:ext cx="3520440" cy="384048"/>
+          </a:xfrm>
+          <a:prstGeom prst="rect">
+            <a:avLst/>
+          </a:prstGeom>
+          <a:noFill/>
+          <a:ln/>
+        </p:spPr>
+        <p:txBody>
+          <a:bodyPr wrap="square" lIns="0" tIns="0" rIns="0" bIns="0" rtlCol="0" anchor="ctr">
+            <a:normAutofit/>
+          </a:bodyPr>
+          <a:lstStyle/>
+          <a:p>
+            <a:pPr algn="l" indent="0" marL="0">
+              <a:buNone/>
+            </a:pPr>
+            <a:r>
+              <a:rPr lang="en-US" sz="1150" dirty="0">
+                <a:solidFill>
+                  <a:srgbClr val="ECEFE9"/>
+                </a:solidFill>
+                <a:latin typeface="Inter" pitchFamily="34" charset="0"/>
+                <a:ea typeface="Inter" pitchFamily="34" charset="-122"/>
+                <a:cs typeface="Inter" pitchFamily="34" charset="-120"/>
+              </a:rPr>
+              <a:t>RDS, one shared db.t4g.small</a:t>
+            </a:r>
+            <a:endParaRPr lang="en-US" sz="1150" dirty="0"/>
+          </a:p>
+        </p:txBody>
+      </p:sp>
+      <p:sp>
+        <p:nvSpPr>
+          <p:cNvPr id="44" name="Text 42"/>
+          <p:cNvSpPr/>
+          <p:nvPr/>
+        </p:nvSpPr>
+        <p:spPr>
+          <a:xfrm>
+            <a:off x="10058400" y="4087368"/>
+            <a:ext cx="960120" cy="384048"/>
+          </a:xfrm>
+          <a:prstGeom prst="rect">
+            <a:avLst/>
+          </a:prstGeom>
+          <a:noFill/>
+          <a:ln/>
+        </p:spPr>
+        <p:txBody>
+          <a:bodyPr wrap="square" lIns="0" tIns="0" rIns="0" bIns="0" rtlCol="0" anchor="ctr">
+            <a:normAutofit/>
+          </a:bodyPr>
+          <a:lstStyle/>
+          <a:p>
+            <a:pPr algn="r" indent="0" marL="0">
+              <a:buNone/>
+            </a:pPr>
+            <a:r>
+              <a:rPr lang="en-US" sz="1300" b="1" dirty="0">
+                <a:solidFill>
+                  <a:srgbClr val="ECEFE9"/>
+                </a:solidFill>
+                <a:latin typeface="JetBrains Mono" pitchFamily="34" charset="0"/>
+                <a:ea typeface="JetBrains Mono" pitchFamily="34" charset="-122"/>
+                <a:cs typeface="JetBrains Mono" pitchFamily="34" charset="-120"/>
+              </a:rPr>
+              <a:t>$25.66</a:t>
+            </a:r>
+            <a:endParaRPr lang="en-US" sz="1300" dirty="0"/>
+          </a:p>
+        </p:txBody>
+      </p:sp>
+      <p:sp>
+        <p:nvSpPr>
+          <p:cNvPr id="45" name="Shape 43"/>
+          <p:cNvSpPr/>
+          <p:nvPr/>
+        </p:nvSpPr>
+        <p:spPr>
+          <a:xfrm>
+            <a:off x="6473952" y="4562856"/>
+            <a:ext cx="4636008" cy="0"/>
+          </a:xfrm>
+          <a:prstGeom prst="line">
+            <a:avLst/>
+          </a:prstGeom>
+          <a:noFill/>
+          <a:ln w="12700">
+            <a:solidFill>
+              <a:srgbClr val="2A2F2C"/>
+            </a:solidFill>
+            <a:prstDash val="solid"/>
+          </a:ln>
+        </p:spPr>
+      </p:sp>
+      <p:sp>
+        <p:nvSpPr>
+          <p:cNvPr id="46" name="Text 44"/>
+          <p:cNvSpPr/>
+          <p:nvPr/>
+        </p:nvSpPr>
+        <p:spPr>
+          <a:xfrm>
+            <a:off x="6537960" y="4590288"/>
+            <a:ext cx="3520440" cy="384048"/>
+          </a:xfrm>
+          <a:prstGeom prst="rect">
+            <a:avLst/>
+          </a:prstGeom>
+          <a:noFill/>
+          <a:ln/>
+        </p:spPr>
+        <p:txBody>
+          <a:bodyPr wrap="square" lIns="0" tIns="0" rIns="0" bIns="0" rtlCol="0" anchor="ctr">
+            <a:normAutofit/>
+          </a:bodyPr>
+          <a:lstStyle/>
+          <a:p>
+            <a:pPr algn="l" indent="0" marL="0">
+              <a:buNone/>
+            </a:pPr>
+            <a:r>
+              <a:rPr lang="en-US" sz="1150" dirty="0">
+                <a:solidFill>
+                  <a:srgbClr val="ECEFE9"/>
+                </a:solidFill>
+                <a:latin typeface="Inter" pitchFamily="34" charset="0"/>
+                <a:ea typeface="Inter" pitchFamily="34" charset="-122"/>
+                <a:cs typeface="Inter" pitchFamily="34" charset="-120"/>
+              </a:rPr>
+              <a:t>Lightsail managed PostgreSQL 2 GB</a:t>
+            </a:r>
+            <a:endParaRPr lang="en-US" sz="1150" dirty="0"/>
+          </a:p>
+        </p:txBody>
+      </p:sp>
+      <p:sp>
+        <p:nvSpPr>
+          <p:cNvPr id="47" name="Text 45"/>
+          <p:cNvSpPr/>
+          <p:nvPr/>
+        </p:nvSpPr>
+        <p:spPr>
+          <a:xfrm>
+            <a:off x="10058400" y="4590288"/>
+            <a:ext cx="960120" cy="384048"/>
+          </a:xfrm>
+          <a:prstGeom prst="rect">
+            <a:avLst/>
+          </a:prstGeom>
+          <a:noFill/>
+          <a:ln/>
+        </p:spPr>
+        <p:txBody>
+          <a:bodyPr wrap="square" lIns="0" tIns="0" rIns="0" bIns="0" rtlCol="0" anchor="ctr">
+            <a:normAutofit/>
+          </a:bodyPr>
+          <a:lstStyle/>
+          <a:p>
+            <a:pPr algn="r" indent="0" marL="0">
+              <a:buNone/>
+            </a:pPr>
+            <a:r>
+              <a:rPr lang="en-US" sz="1300" b="1" dirty="0">
+                <a:solidFill>
+                  <a:srgbClr val="ECEFE9"/>
+                </a:solidFill>
+                <a:latin typeface="JetBrains Mono" pitchFamily="34" charset="0"/>
+                <a:ea typeface="JetBrains Mono" pitchFamily="34" charset="-122"/>
+                <a:cs typeface="JetBrains Mono" pitchFamily="34" charset="-120"/>
+              </a:rPr>
+              <a:t>$30</a:t>
+            </a:r>
+            <a:endParaRPr lang="en-US" sz="1300" dirty="0"/>
+          </a:p>
+        </p:txBody>
+      </p:sp>
+      <p:sp>
+        <p:nvSpPr>
+          <p:cNvPr id="48" name="Shape 46"/>
+          <p:cNvSpPr/>
+          <p:nvPr/>
+        </p:nvSpPr>
+        <p:spPr>
+          <a:xfrm>
+            <a:off x="6419088" y="5074920"/>
+            <a:ext cx="4800600" cy="457200"/>
+          </a:xfrm>
+          <a:prstGeom prst="roundRect">
+            <a:avLst>
+              <a:gd name="adj" fmla="val 16000"/>
+            </a:avLst>
+          </a:prstGeom>
+          <a:solidFill>
+            <a:srgbClr val="202E25"/>
+          </a:solidFill>
+          <a:ln w="12700">
+            <a:solidFill>
+              <a:srgbClr val="202E25"/>
+            </a:solidFill>
+            <a:prstDash val="solid"/>
+          </a:ln>
+        </p:spPr>
+      </p:sp>
+      <p:sp>
+        <p:nvSpPr>
+          <p:cNvPr id="49" name="Text 47"/>
+          <p:cNvSpPr/>
+          <p:nvPr/>
+        </p:nvSpPr>
+        <p:spPr>
+          <a:xfrm>
+            <a:off x="6537960" y="5093208"/>
+            <a:ext cx="3520440" cy="384048"/>
+          </a:xfrm>
+          <a:prstGeom prst="rect">
+            <a:avLst/>
+          </a:prstGeom>
+          <a:noFill/>
+          <a:ln/>
+        </p:spPr>
+        <p:txBody>
+          <a:bodyPr wrap="square" lIns="0" tIns="0" rIns="0" bIns="0" rtlCol="0" anchor="ctr">
+            <a:normAutofit/>
+          </a:bodyPr>
+          <a:lstStyle/>
+          <a:p>
+            <a:pPr algn="l" indent="0" marL="0">
+              <a:buNone/>
+            </a:pPr>
+            <a:r>
+              <a:rPr lang="en-US" sz="1150" dirty="0">
+                <a:solidFill>
+                  <a:srgbClr val="8FC7A2"/>
+                </a:solidFill>
+                <a:latin typeface="Inter" pitchFamily="34" charset="0"/>
+                <a:ea typeface="Inter" pitchFamily="34" charset="-122"/>
+                <a:cs typeface="Inter" pitchFamily="34" charset="-120"/>
+              </a:rPr>
+              <a:t>Pgfy on Lightsail + S3</a:t>
+            </a:r>
+            <a:endParaRPr lang="en-US" sz="1150" dirty="0"/>
+          </a:p>
+        </p:txBody>
+      </p:sp>
+      <p:sp>
+        <p:nvSpPr>
+          <p:cNvPr id="50" name="Text 48"/>
+          <p:cNvSpPr/>
+          <p:nvPr/>
+        </p:nvSpPr>
+        <p:spPr>
+          <a:xfrm>
+            <a:off x="10058400" y="5093208"/>
+            <a:ext cx="960120" cy="384048"/>
+          </a:xfrm>
+          <a:prstGeom prst="rect">
+            <a:avLst/>
+          </a:prstGeom>
+          <a:noFill/>
+          <a:ln/>
+        </p:spPr>
+        <p:txBody>
+          <a:bodyPr wrap="square" lIns="0" tIns="0" rIns="0" bIns="0" rtlCol="0" anchor="ctr">
+            <a:normAutofit/>
+          </a:bodyPr>
+          <a:lstStyle/>
+          <a:p>
+            <a:pPr algn="r" indent="0" marL="0">
+              <a:buNone/>
+            </a:pPr>
+            <a:r>
+              <a:rPr lang="en-US" sz="1300" b="1" dirty="0">
+                <a:solidFill>
+                  <a:srgbClr val="8FC7A2"/>
+                </a:solidFill>
+                <a:latin typeface="JetBrains Mono" pitchFamily="34" charset="0"/>
+                <a:ea typeface="JetBrains Mono" pitchFamily="34" charset="-122"/>
+                <a:cs typeface="JetBrains Mono" pitchFamily="34" charset="-120"/>
+              </a:rPr>
               <a:t>$12.23</a:t>
             </a:r>
             <a:endParaRPr lang="en-US" sz="1300" dirty="0"/>
@@ -4674,14 +5192,14 @@
       </p:sp>
       <p:sp>
         <p:nvSpPr>
-          <p:cNvPr id="37" name="Text 35"/>
-          <p:cNvSpPr/>
-          <p:nvPr/>
-        </p:nvSpPr>
-        <p:spPr>
-          <a:xfrm>
-            <a:off x="6473952" y="4983480"/>
-            <a:ext cx="4599432" cy="310896"/>
+          <p:cNvPr id="51" name="Text 49"/>
+          <p:cNvSpPr/>
+          <p:nvPr/>
+        </p:nvSpPr>
+        <p:spPr>
+          <a:xfrm>
+            <a:off x="6473952" y="5614416"/>
+            <a:ext cx="4599432" cy="274320"/>
           </a:xfrm>
           <a:prstGeom prst="rect">
             <a:avLst/>

</xml_diff>

<commit_message>
docs(deck): story slide as a three-step narrative, confident close, roadmap trim; fix pptx wordmark
Co-Authored-By: Claude Opus 5 <noreply@anthropic.com>
</commit_message>
<xml_diff>
--- a/docs/deck/pgfy-pitch.pptx
+++ b/docs/deck/pgfy-pitch.pptx
@@ -1171,7 +1171,7 @@
         <p:spPr>
           <a:xfrm>
             <a:off x="877824" y="292608"/>
-            <a:ext cx="640080" cy="228600"/>
+            <a:ext cx="457200" cy="228600"/>
           </a:xfrm>
           <a:prstGeom prst="rect">
             <a:avLst/>
@@ -1189,13 +1189,52 @@
             <a:r>
               <a:rPr lang="en-US" sz="1200" b="1" dirty="0">
                 <a:solidFill>
-                  <a:srgbClr val="000000"/>
-                </a:solidFill>
-                <a:latin typeface="Inter" pitchFamily="34" charset="0"/>
-                <a:ea typeface="Inter" pitchFamily="34" charset="-122"/>
-                <a:cs typeface="Inter" pitchFamily="34" charset="-120"/>
-              </a:rPr>
-              <a:t>[object Object],[object Object]</a:t>
+                  <a:srgbClr val="ECEFE9"/>
+                </a:solidFill>
+                <a:latin typeface="Inter" pitchFamily="34" charset="0"/>
+                <a:ea typeface="Inter" pitchFamily="34" charset="-122"/>
+                <a:cs typeface="Inter" pitchFamily="34" charset="-120"/>
+              </a:rPr>
+              <a:t>pgfy</a:t>
+            </a:r>
+            <a:endParaRPr lang="en-US" sz="1200" dirty="0"/>
+          </a:p>
+        </p:txBody>
+      </p:sp>
+      <p:sp>
+        <p:nvSpPr>
+          <p:cNvPr id="4" name="Text 1"/>
+          <p:cNvSpPr/>
+          <p:nvPr/>
+        </p:nvSpPr>
+        <p:spPr>
+          <a:xfrm>
+            <a:off x="1220724" y="292608"/>
+            <a:ext cx="109728" cy="228600"/>
+          </a:xfrm>
+          <a:prstGeom prst="rect">
+            <a:avLst/>
+          </a:prstGeom>
+          <a:noFill/>
+          <a:ln/>
+        </p:spPr>
+        <p:txBody>
+          <a:bodyPr wrap="square" lIns="0" tIns="0" rIns="0" bIns="0" rtlCol="0" anchor="ctr"/>
+          <a:lstStyle/>
+          <a:p>
+            <a:pPr indent="0" marL="0">
+              <a:buNone/>
+            </a:pPr>
+            <a:r>
+              <a:rPr lang="en-US" sz="1200" b="1" dirty="0">
+                <a:solidFill>
+                  <a:srgbClr val="8FC7A2"/>
+                </a:solidFill>
+                <a:latin typeface="Inter" pitchFamily="34" charset="0"/>
+                <a:ea typeface="Inter" pitchFamily="34" charset="-122"/>
+                <a:cs typeface="Inter" pitchFamily="34" charset="-120"/>
+              </a:rPr>
+              <a:t>.</a:t>
             </a:r>
             <a:endParaRPr lang="en-US" sz="1200" dirty="0"/>
           </a:p>
@@ -1839,11 +1878,11 @@
         <p:spPr>
           <a:xfrm>
             <a:off x="749808" y="1353312"/>
-            <a:ext cx="3493008" cy="3520440"/>
+            <a:ext cx="3154680" cy="3931920"/>
           </a:xfrm>
           <a:prstGeom prst="roundRect">
             <a:avLst>
-              <a:gd name="adj" fmla="val 2094"/>
+              <a:gd name="adj" fmla="val 2319"/>
             </a:avLst>
           </a:prstGeom>
           <a:solidFill>
@@ -1865,8 +1904,8 @@
         </p:nvSpPr>
         <p:spPr>
           <a:xfrm>
-            <a:off x="978408" y="1572768"/>
-            <a:ext cx="3017520" cy="384048"/>
+            <a:off x="969264" y="1536192"/>
+            <a:ext cx="2743200" cy="219456"/>
           </a:xfrm>
           <a:prstGeom prst="rect">
             <a:avLst/>
@@ -1884,7 +1923,48 @@
               <a:buNone/>
             </a:pPr>
             <a:r>
-              <a:rPr lang="en-US" sz="2100" b="1" dirty="0">
+              <a:rPr lang="en-US" sz="850" b="1" spc="110" kern="0" dirty="0">
+                <a:solidFill>
+                  <a:srgbClr val="A2AAA0"/>
+                </a:solidFill>
+                <a:latin typeface="Inter" pitchFamily="34" charset="0"/>
+                <a:ea typeface="Inter" pitchFamily="34" charset="-122"/>
+                <a:cs typeface="Inter" pitchFamily="34" charset="-120"/>
+              </a:rPr>
+              <a:t>01 · THE BILL</a:t>
+            </a:r>
+            <a:endParaRPr lang="en-US" sz="850" dirty="0"/>
+          </a:p>
+        </p:txBody>
+      </p:sp>
+      <p:sp>
+        <p:nvSpPr>
+          <p:cNvPr id="5" name="Text 3"/>
+          <p:cNvSpPr/>
+          <p:nvPr/>
+        </p:nvSpPr>
+        <p:spPr>
+          <a:xfrm>
+            <a:off x="969264" y="1810512"/>
+            <a:ext cx="2743200" cy="384048"/>
+          </a:xfrm>
+          <a:prstGeom prst="rect">
+            <a:avLst/>
+          </a:prstGeom>
+          <a:noFill/>
+          <a:ln/>
+        </p:spPr>
+        <p:txBody>
+          <a:bodyPr wrap="square" lIns="0" tIns="0" rIns="0" bIns="0" rtlCol="0" anchor="ctr">
+            <a:normAutofit/>
+          </a:bodyPr>
+          <a:lstStyle/>
+          <a:p>
+            <a:pPr algn="l" indent="0" marL="0">
+              <a:buNone/>
+            </a:pPr>
+            <a:r>
+              <a:rPr lang="en-US" sz="1900" b="1" dirty="0">
                 <a:solidFill>
                   <a:srgbClr val="ECEFE9"/>
                 </a:solidFill>
@@ -1892,22 +1972,22 @@
                 <a:ea typeface="Inter" pitchFamily="34" charset="-122"/>
                 <a:cs typeface="Inter" pitchFamily="34" charset="-120"/>
               </a:rPr>
-              <a:t>$20 / month</a:t>
-            </a:r>
-            <a:endParaRPr lang="en-US" sz="2100" dirty="0"/>
-          </a:p>
-        </p:txBody>
-      </p:sp>
-      <p:sp>
-        <p:nvSpPr>
-          <p:cNvPr id="5" name="Text 3"/>
-          <p:cNvSpPr/>
-          <p:nvPr/>
-        </p:nvSpPr>
-        <p:spPr>
-          <a:xfrm>
-            <a:off x="978408" y="2057400"/>
-            <a:ext cx="3017520" cy="1600200"/>
+              <a:t>“Hosting is on you.”</a:t>
+            </a:r>
+            <a:endParaRPr lang="en-US" sz="1900" dirty="0"/>
+          </a:p>
+        </p:txBody>
+      </p:sp>
+      <p:sp>
+        <p:nvSpPr>
+          <p:cNvPr id="6" name="Text 4"/>
+          <p:cNvSpPr/>
+          <p:nvPr/>
+        </p:nvSpPr>
+        <p:spPr>
+          <a:xfrm>
+            <a:off x="969264" y="2267712"/>
+            <a:ext cx="2724912" cy="2377440"/>
           </a:xfrm>
           <a:prstGeom prst="rect">
             <a:avLst/>
@@ -1925,7 +2005,7 @@
               <a:buNone/>
             </a:pPr>
             <a:r>
-              <a:rPr lang="en-US" sz="1500" dirty="0">
+              <a:rPr lang="en-US" sz="1350" dirty="0">
                 <a:solidFill>
                   <a:srgbClr val="ECEFE9"/>
                 </a:solidFill>
@@ -1933,26 +2013,54 @@
                 <a:ea typeface="Inter" pitchFamily="34" charset="-122"/>
                 <a:cs typeface="Inter" pitchFamily="34" charset="-120"/>
               </a:rPr>
-              <a:t>$240 a year for one Postgres — on top of AI and VPS bills, for an app with a tiny audience. “Hosting is on you.”</a:t>
-            </a:r>
-            <a:endParaRPr lang="en-US" sz="1500" dirty="0"/>
-          </a:p>
-        </p:txBody>
-      </p:sp>
-      <p:sp>
-        <p:nvSpPr>
-          <p:cNvPr id="6" name="Shape 4"/>
-          <p:cNvSpPr/>
-          <p:nvPr/>
-        </p:nvSpPr>
-        <p:spPr>
-          <a:xfrm>
-            <a:off x="4480560" y="1353312"/>
-            <a:ext cx="3493008" cy="3520440"/>
+              <a:t>A client wouldn’t pay for infrastructure. One managed Postgres was </a:t>
+            </a:r>
+            <a:pPr algn="l" indent="0" marL="0">
+              <a:buNone/>
+            </a:pPr>
+            <a:r>
+              <a:rPr lang="en-US" sz="1350" b="1" dirty="0">
+                <a:solidFill>
+                  <a:srgbClr val="ECEFE9"/>
+                </a:solidFill>
+                <a:latin typeface="Inter" pitchFamily="34" charset="0"/>
+                <a:ea typeface="Inter" pitchFamily="34" charset="-122"/>
+                <a:cs typeface="Inter" pitchFamily="34" charset="-120"/>
+              </a:rPr>
+              <a:t>$20 a month — $240 a year</a:t>
+            </a:r>
+            <a:pPr algn="l" indent="0" marL="0">
+              <a:buNone/>
+            </a:pPr>
+            <a:r>
+              <a:rPr lang="en-US" sz="1350" dirty="0">
+                <a:solidFill>
+                  <a:srgbClr val="ECEFE9"/>
+                </a:solidFill>
+                <a:latin typeface="Inter" pitchFamily="34" charset="0"/>
+                <a:ea typeface="Inter" pitchFamily="34" charset="-122"/>
+                <a:cs typeface="Inter" pitchFamily="34" charset="-120"/>
+              </a:rPr>
+              <a:t> — on top of AI and VPS bills, for an app with a tiny audience. Multiply by every small project an agency runs.</a:t>
+            </a:r>
+            <a:endParaRPr lang="en-US" sz="1350" dirty="0"/>
+          </a:p>
+        </p:txBody>
+      </p:sp>
+      <p:sp>
+        <p:nvSpPr>
+          <p:cNvPr id="7" name="Shape 5"/>
+          <p:cNvSpPr/>
+          <p:nvPr/>
+        </p:nvSpPr>
+        <p:spPr>
+          <a:xfrm>
+            <a:off x="4078224" y="1353312"/>
+            <a:ext cx="4160520" cy="3931920"/>
           </a:xfrm>
           <a:prstGeom prst="roundRect">
             <a:avLst>
-              <a:gd name="adj" fmla="val 2094"/>
+              <a:gd name="adj" fmla="val 1860"/>
             </a:avLst>
           </a:prstGeom>
           <a:solidFill>
@@ -1968,14 +2076,14 @@
       </p:sp>
       <p:sp>
         <p:nvSpPr>
-          <p:cNvPr id="7" name="Text 5"/>
-          <p:cNvSpPr/>
-          <p:nvPr/>
-        </p:nvSpPr>
-        <p:spPr>
-          <a:xfrm>
-            <a:off x="4709160" y="1572768"/>
-            <a:ext cx="3017520" cy="384048"/>
+          <p:cNvPr id="8" name="Text 6"/>
+          <p:cNvSpPr/>
+          <p:nvPr/>
+        </p:nvSpPr>
+        <p:spPr>
+          <a:xfrm>
+            <a:off x="4297680" y="1536192"/>
+            <a:ext cx="2743200" cy="219456"/>
           </a:xfrm>
           <a:prstGeom prst="rect">
             <a:avLst/>
@@ -1993,7 +2101,89 @@
               <a:buNone/>
             </a:pPr>
             <a:r>
-              <a:rPr lang="en-US" sz="2100" b="1" dirty="0">
+              <a:rPr lang="en-US" sz="850" b="1" spc="110" kern="0" dirty="0">
+                <a:solidFill>
+                  <a:srgbClr val="A2AAA0"/>
+                </a:solidFill>
+                <a:latin typeface="Inter" pitchFamily="34" charset="0"/>
+                <a:ea typeface="Inter" pitchFamily="34" charset="-122"/>
+                <a:cs typeface="Inter" pitchFamily="34" charset="-120"/>
+              </a:rPr>
+              <a:t>02 · WHAT I TRIED</a:t>
+            </a:r>
+            <a:endParaRPr lang="en-US" sz="850" dirty="0"/>
+          </a:p>
+        </p:txBody>
+      </p:sp>
+      <p:sp>
+        <p:nvSpPr>
+          <p:cNvPr id="9" name="Text 7"/>
+          <p:cNvSpPr/>
+          <p:nvPr/>
+        </p:nvSpPr>
+        <p:spPr>
+          <a:xfrm>
+            <a:off x="4297680" y="1874520"/>
+            <a:ext cx="868680" cy="365760"/>
+          </a:xfrm>
+          <a:prstGeom prst="rect">
+            <a:avLst/>
+          </a:prstGeom>
+          <a:noFill/>
+          <a:ln/>
+        </p:spPr>
+        <p:txBody>
+          <a:bodyPr wrap="square" lIns="0" tIns="0" rIns="0" bIns="0" rtlCol="0" anchor="t">
+            <a:normAutofit/>
+          </a:bodyPr>
+          <a:lstStyle/>
+          <a:p>
+            <a:pPr algn="l" indent="0" marL="0">
+              <a:buNone/>
+            </a:pPr>
+            <a:r>
+              <a:rPr lang="en-US" sz="1300" b="1" dirty="0">
+                <a:solidFill>
+                  <a:srgbClr val="8FC7A2"/>
+                </a:solidFill>
+                <a:latin typeface="Inter" pitchFamily="34" charset="0"/>
+                <a:ea typeface="Inter" pitchFamily="34" charset="-122"/>
+                <a:cs typeface="Inter" pitchFamily="34" charset="-120"/>
+              </a:rPr>
+              <a:t>Dokploy</a:t>
+            </a:r>
+            <a:endParaRPr lang="en-US" sz="1300" dirty="0"/>
+          </a:p>
+        </p:txBody>
+      </p:sp>
+      <p:sp>
+        <p:nvSpPr>
+          <p:cNvPr id="10" name="Text 8"/>
+          <p:cNvSpPr/>
+          <p:nvPr/>
+        </p:nvSpPr>
+        <p:spPr>
+          <a:xfrm>
+            <a:off x="5175504" y="1874520"/>
+            <a:ext cx="2834640" cy="914400"/>
+          </a:xfrm>
+          <a:prstGeom prst="rect">
+            <a:avLst/>
+          </a:prstGeom>
+          <a:noFill/>
+          <a:ln/>
+        </p:spPr>
+        <p:txBody>
+          <a:bodyPr wrap="square" lIns="0" tIns="0" rIns="0" bIns="0" rtlCol="0" anchor="t">
+            <a:normAutofit/>
+          </a:bodyPr>
+          <a:lstStyle/>
+          <a:p>
+            <a:pPr algn="l" indent="0" marL="0">
+              <a:buNone/>
+            </a:pPr>
+            <a:r>
+              <a:rPr lang="en-US" sz="1250" dirty="0">
                 <a:solidFill>
                   <a:srgbClr val="ECEFE9"/>
                 </a:solidFill>
@@ -2001,63 +2191,22 @@
                 <a:ea typeface="Inter" pitchFamily="34" charset="-122"/>
                 <a:cs typeface="Inter" pitchFamily="34" charset="-120"/>
               </a:rPr>
-              <a:t>Dokploy · RDS</a:t>
-            </a:r>
-            <a:endParaRPr lang="en-US" sz="2100" dirty="0"/>
-          </a:p>
-        </p:txBody>
-      </p:sp>
-      <p:sp>
-        <p:nvSpPr>
-          <p:cNvPr id="8" name="Text 6"/>
-          <p:cNvSpPr/>
-          <p:nvPr/>
-        </p:nvSpPr>
-        <p:spPr>
-          <a:xfrm>
-            <a:off x="4709160" y="2057400"/>
-            <a:ext cx="3017520" cy="1600200"/>
-          </a:xfrm>
-          <a:prstGeom prst="rect">
-            <a:avLst/>
-          </a:prstGeom>
-          <a:noFill/>
-          <a:ln/>
-        </p:spPr>
-        <p:txBody>
-          <a:bodyPr wrap="square" lIns="0" tIns="0" rIns="0" bIns="0" rtlCol="0" anchor="t">
-            <a:normAutofit/>
-          </a:bodyPr>
-          <a:lstStyle/>
-          <a:p>
-            <a:pPr algn="l" indent="0" marL="0">
-              <a:buNone/>
-            </a:pPr>
-            <a:r>
-              <a:rPr lang="en-US" sz="1500" dirty="0">
-                <a:solidFill>
-                  <a:srgbClr val="ECEFE9"/>
-                </a:solidFill>
-                <a:latin typeface="Inter" pitchFamily="34" charset="0"/>
-                <a:ea typeface="Inter" pitchFamily="34" charset="-122"/>
-                <a:cs typeface="Inter" pitchFamily="34" charset="-120"/>
-              </a:rPr>
-              <a:t>One-click self-hosting spoiled me, but its databases weren’t managed the way I needed.</a:t>
-            </a:r>
-            <a:endParaRPr lang="en-US" sz="1500" dirty="0"/>
-          </a:p>
-        </p:txBody>
-      </p:sp>
-      <p:sp>
-        <p:nvSpPr>
-          <p:cNvPr id="9" name="Shape 7"/>
-          <p:cNvSpPr/>
-          <p:nvPr/>
-        </p:nvSpPr>
-        <p:spPr>
-          <a:xfrm>
-            <a:off x="4709160" y="3767328"/>
-            <a:ext cx="3017520" cy="0"/>
+              <a:t>One-click self-hosting, but its databases weren’t managed the way I needed.</a:t>
+            </a:r>
+            <a:endParaRPr lang="en-US" sz="1250" dirty="0"/>
+          </a:p>
+        </p:txBody>
+      </p:sp>
+      <p:sp>
+        <p:nvSpPr>
+          <p:cNvPr id="11" name="Shape 9"/>
+          <p:cNvSpPr/>
+          <p:nvPr/>
+        </p:nvSpPr>
+        <p:spPr>
+          <a:xfrm>
+            <a:off x="4297680" y="2880360"/>
+            <a:ext cx="3721608" cy="0"/>
           </a:xfrm>
           <a:prstGeom prst="line">
             <a:avLst/>
@@ -2073,14 +2222,14 @@
       </p:sp>
       <p:sp>
         <p:nvSpPr>
-          <p:cNvPr id="10" name="Text 8"/>
-          <p:cNvSpPr/>
-          <p:nvPr/>
-        </p:nvSpPr>
-        <p:spPr>
-          <a:xfrm>
-            <a:off x="4709160" y="3858768"/>
-            <a:ext cx="3017520" cy="731520"/>
+          <p:cNvPr id="12" name="Text 10"/>
+          <p:cNvSpPr/>
+          <p:nvPr/>
+        </p:nvSpPr>
+        <p:spPr>
+          <a:xfrm>
+            <a:off x="4297680" y="2971800"/>
+            <a:ext cx="868680" cy="365760"/>
           </a:xfrm>
           <a:prstGeom prst="rect">
             <a:avLst/>
@@ -2098,15 +2247,56 @@
               <a:buNone/>
             </a:pPr>
             <a:r>
+              <a:rPr lang="en-US" sz="1300" b="1" dirty="0">
+                <a:solidFill>
+                  <a:srgbClr val="8FC7A2"/>
+                </a:solidFill>
+                <a:latin typeface="Inter" pitchFamily="34" charset="0"/>
+                <a:ea typeface="Inter" pitchFamily="34" charset="-122"/>
+                <a:cs typeface="Inter" pitchFamily="34" charset="-120"/>
+              </a:rPr>
+              <a:t>RDS</a:t>
+            </a:r>
+            <a:endParaRPr lang="en-US" sz="1300" dirty="0"/>
+          </a:p>
+        </p:txBody>
+      </p:sp>
+      <p:sp>
+        <p:nvSpPr>
+          <p:cNvPr id="13" name="Text 11"/>
+          <p:cNvSpPr/>
+          <p:nvPr/>
+        </p:nvSpPr>
+        <p:spPr>
+          <a:xfrm>
+            <a:off x="5175504" y="2971800"/>
+            <a:ext cx="2834640" cy="914400"/>
+          </a:xfrm>
+          <a:prstGeom prst="rect">
+            <a:avLst/>
+          </a:prstGeom>
+          <a:noFill/>
+          <a:ln/>
+        </p:spPr>
+        <p:txBody>
+          <a:bodyPr wrap="square" lIns="0" tIns="0" rIns="0" bIns="0" rtlCol="0" anchor="t">
+            <a:normAutofit/>
+          </a:bodyPr>
+          <a:lstStyle/>
+          <a:p>
+            <a:pPr algn="l" indent="0" marL="0">
+              <a:buNone/>
+            </a:pPr>
+            <a:r>
               <a:rPr lang="en-US" sz="1250" dirty="0">
                 <a:solidFill>
-                  <a:srgbClr val="A2AAA0"/>
-                </a:solidFill>
-                <a:latin typeface="Inter" pitchFamily="34" charset="0"/>
-                <a:ea typeface="Inter" pitchFamily="34" charset="-122"/>
-                <a:cs typeface="Inter" pitchFamily="34" charset="-120"/>
-              </a:rPr>
-              <a:t>RDS documents many databases per instance — then leaves every role, password and backup to you.</a:t>
+                  <a:srgbClr val="ECEFE9"/>
+                </a:solidFill>
+                <a:latin typeface="Inter" pitchFamily="34" charset="0"/>
+                <a:ea typeface="Inter" pitchFamily="34" charset="-122"/>
+                <a:cs typeface="Inter" pitchFamily="34" charset="-120"/>
+              </a:rPr>
+              <a:t>Documents many databases per instance — then leaves every role, password and backup to you.</a:t>
             </a:r>
             <a:endParaRPr lang="en-US" sz="1250" dirty="0"/>
           </a:p>
@@ -2114,23 +2304,19 @@
       </p:sp>
       <p:sp>
         <p:nvSpPr>
-          <p:cNvPr id="11" name="Shape 9"/>
-          <p:cNvSpPr/>
-          <p:nvPr/>
-        </p:nvSpPr>
-        <p:spPr>
-          <a:xfrm>
-            <a:off x="8211312" y="1353312"/>
-            <a:ext cx="3493008" cy="3520440"/>
-          </a:xfrm>
-          <a:prstGeom prst="roundRect">
-            <a:avLst>
-              <a:gd name="adj" fmla="val 2094"/>
-            </a:avLst>
-          </a:prstGeom>
-          <a:solidFill>
-            <a:srgbClr val="191E1B"/>
-          </a:solidFill>
+          <p:cNvPr id="14" name="Shape 12"/>
+          <p:cNvSpPr/>
+          <p:nvPr/>
+        </p:nvSpPr>
+        <p:spPr>
+          <a:xfrm>
+            <a:off x="4297680" y="3977640"/>
+            <a:ext cx="3721608" cy="0"/>
+          </a:xfrm>
+          <a:prstGeom prst="line">
+            <a:avLst/>
+          </a:prstGeom>
+          <a:noFill/>
           <a:ln w="12700">
             <a:solidFill>
               <a:srgbClr val="2A2F2C"/>
@@ -2141,23 +2327,23 @@
       </p:sp>
       <p:sp>
         <p:nvSpPr>
-          <p:cNvPr id="12" name="Text 10"/>
-          <p:cNvSpPr/>
-          <p:nvPr/>
-        </p:nvSpPr>
-        <p:spPr>
-          <a:xfrm>
-            <a:off x="8439912" y="1572768"/>
-            <a:ext cx="3017520" cy="384048"/>
-          </a:xfrm>
-          <a:prstGeom prst="rect">
-            <a:avLst/>
-          </a:prstGeom>
-          <a:noFill/>
-          <a:ln/>
-        </p:spPr>
-        <p:txBody>
-          <a:bodyPr wrap="square" lIns="0" tIns="0" rIns="0" bIns="0" rtlCol="0" anchor="ctr">
+          <p:cNvPr id="15" name="Text 13"/>
+          <p:cNvSpPr/>
+          <p:nvPr/>
+        </p:nvSpPr>
+        <p:spPr>
+          <a:xfrm>
+            <a:off x="4297680" y="4069080"/>
+            <a:ext cx="868680" cy="365760"/>
+          </a:xfrm>
+          <a:prstGeom prst="rect">
+            <a:avLst/>
+          </a:prstGeom>
+          <a:noFill/>
+          <a:ln/>
+        </p:spPr>
+        <p:txBody>
+          <a:bodyPr wrap="square" lIns="0" tIns="0" rIns="0" bIns="0" rtlCol="0" anchor="t">
             <a:normAutofit/>
           </a:bodyPr>
           <a:lstStyle/>
@@ -2166,7 +2352,48 @@
               <a:buNone/>
             </a:pPr>
             <a:r>
-              <a:rPr lang="en-US" sz="2100" b="1" dirty="0">
+              <a:rPr lang="en-US" sz="1300" b="1" dirty="0">
+                <a:solidFill>
+                  <a:srgbClr val="8FC7A2"/>
+                </a:solidFill>
+                <a:latin typeface="Inter" pitchFamily="34" charset="0"/>
+                <a:ea typeface="Inter" pitchFamily="34" charset="-122"/>
+                <a:cs typeface="Inter" pitchFamily="34" charset="-120"/>
+              </a:rPr>
+              <a:t>Neon</a:t>
+            </a:r>
+            <a:endParaRPr lang="en-US" sz="1300" dirty="0"/>
+          </a:p>
+        </p:txBody>
+      </p:sp>
+      <p:sp>
+        <p:nvSpPr>
+          <p:cNvPr id="16" name="Text 14"/>
+          <p:cNvSpPr/>
+          <p:nvPr/>
+        </p:nvSpPr>
+        <p:spPr>
+          <a:xfrm>
+            <a:off x="5175504" y="4069080"/>
+            <a:ext cx="2834640" cy="914400"/>
+          </a:xfrm>
+          <a:prstGeom prst="rect">
+            <a:avLst/>
+          </a:prstGeom>
+          <a:noFill/>
+          <a:ln/>
+        </p:spPr>
+        <p:txBody>
+          <a:bodyPr wrap="square" lIns="0" tIns="0" rIns="0" bIns="0" rtlCol="0" anchor="t">
+            <a:normAutofit/>
+          </a:bodyPr>
+          <a:lstStyle/>
+          <a:p>
+            <a:pPr algn="l" indent="0" marL="0">
+              <a:buNone/>
+            </a:pPr>
+            <a:r>
+              <a:rPr lang="en-US" sz="1250" dirty="0">
                 <a:solidFill>
                   <a:srgbClr val="ECEFE9"/>
                 </a:solidFill>
@@ -2174,40 +2401,16 @@
                 <a:ea typeface="Inter" pitchFamily="34" charset="-122"/>
                 <a:cs typeface="Inter" pitchFamily="34" charset="-120"/>
               </a:rPr>
-              <a:t>Neon</a:t>
-            </a:r>
-            <a:endParaRPr lang="en-US" sz="2100" dirty="0"/>
-          </a:p>
-        </p:txBody>
-      </p:sp>
-      <p:sp>
-        <p:nvSpPr>
-          <p:cNvPr id="13" name="Text 11"/>
-          <p:cNvSpPr/>
-          <p:nvPr/>
-        </p:nvSpPr>
-        <p:spPr>
-          <a:xfrm>
-            <a:off x="8439912" y="2057400"/>
-            <a:ext cx="3017520" cy="1600200"/>
-          </a:xfrm>
-          <a:prstGeom prst="rect">
-            <a:avLst/>
-          </a:prstGeom>
-          <a:noFill/>
-          <a:ln/>
-        </p:spPr>
-        <p:txBody>
-          <a:bodyPr wrap="square" lIns="0" tIns="0" rIns="0" bIns="0" rtlCol="0" anchor="t">
-            <a:normAutofit/>
-          </a:bodyPr>
-          <a:lstStyle/>
+              <a:t>Workers every 10 s keep it awake — $19.34 per project, always on.</a:t>
+            </a:r>
+            <a:endParaRPr lang="en-US" sz="1250" dirty="0"/>
+          </a:p>
           <a:p>
             <a:pPr algn="l" indent="0" marL="0">
               <a:buNone/>
             </a:pPr>
             <a:r>
-              <a:rPr lang="en-US" sz="1500" dirty="0">
+              <a:rPr lang="en-US" sz="1250" dirty="0">
                 <a:solidFill>
                   <a:srgbClr val="ECEFE9"/>
                 </a:solidFill>
@@ -2215,30 +2418,34 @@
                 <a:ea typeface="Inter" pitchFamily="34" charset="-122"/>
                 <a:cs typeface="Inter" pitchFamily="34" charset="-120"/>
               </a:rPr>
-              <a:t>My apps run workers every 10 s — the database never sleeps.</a:t>
-            </a:r>
-            <a:endParaRPr lang="en-US" sz="1500" dirty="0"/>
-          </a:p>
-        </p:txBody>
-      </p:sp>
-      <p:sp>
-        <p:nvSpPr>
-          <p:cNvPr id="14" name="Shape 12"/>
-          <p:cNvSpPr/>
-          <p:nvPr/>
-        </p:nvSpPr>
-        <p:spPr>
-          <a:xfrm>
-            <a:off x="8439912" y="3767328"/>
-            <a:ext cx="3017520" cy="0"/>
-          </a:xfrm>
-          <a:prstGeom prst="line">
-            <a:avLst/>
-          </a:prstGeom>
-          <a:noFill/>
+              <a:t>0.25 CU × 730 h × $0.106</a:t>
+            </a:r>
+            <a:endParaRPr lang="en-US" sz="1250" dirty="0"/>
+          </a:p>
+        </p:txBody>
+      </p:sp>
+      <p:sp>
+        <p:nvSpPr>
+          <p:cNvPr id="17" name="Shape 15"/>
+          <p:cNvSpPr/>
+          <p:nvPr/>
+        </p:nvSpPr>
+        <p:spPr>
+          <a:xfrm>
+            <a:off x="8412480" y="1353312"/>
+            <a:ext cx="3154680" cy="3931920"/>
+          </a:xfrm>
+          <a:prstGeom prst="roundRect">
+            <a:avLst>
+              <a:gd name="adj" fmla="val 2319"/>
+            </a:avLst>
+          </a:prstGeom>
+          <a:solidFill>
+            <a:srgbClr val="202E25"/>
+          </a:solidFill>
           <a:ln w="12700">
             <a:solidFill>
-              <a:srgbClr val="2A2F2C"/>
+              <a:srgbClr val="2F4A3A"/>
             </a:solidFill>
             <a:prstDash val="solid"/>
           </a:ln>
@@ -2246,14 +2453,55 @@
       </p:sp>
       <p:sp>
         <p:nvSpPr>
-          <p:cNvPr id="15" name="Text 13"/>
-          <p:cNvSpPr/>
-          <p:nvPr/>
-        </p:nvSpPr>
-        <p:spPr>
-          <a:xfrm>
-            <a:off x="8439912" y="3858768"/>
-            <a:ext cx="3017520" cy="731520"/>
+          <p:cNvPr id="18" name="Text 16"/>
+          <p:cNvSpPr/>
+          <p:nvPr/>
+        </p:nvSpPr>
+        <p:spPr>
+          <a:xfrm>
+            <a:off x="8631936" y="1536192"/>
+            <a:ext cx="2743200" cy="219456"/>
+          </a:xfrm>
+          <a:prstGeom prst="rect">
+            <a:avLst/>
+          </a:prstGeom>
+          <a:noFill/>
+          <a:ln/>
+        </p:spPr>
+        <p:txBody>
+          <a:bodyPr wrap="square" lIns="0" tIns="0" rIns="0" bIns="0" rtlCol="0" anchor="ctr">
+            <a:normAutofit/>
+          </a:bodyPr>
+          <a:lstStyle/>
+          <a:p>
+            <a:pPr algn="l" indent="0" marL="0">
+              <a:buNone/>
+            </a:pPr>
+            <a:r>
+              <a:rPr lang="en-US" sz="850" b="1" spc="110" kern="0" dirty="0">
+                <a:solidFill>
+                  <a:srgbClr val="8FC7A2"/>
+                </a:solidFill>
+                <a:latin typeface="Inter" pitchFamily="34" charset="0"/>
+                <a:ea typeface="Inter" pitchFamily="34" charset="-122"/>
+                <a:cs typeface="Inter" pitchFamily="34" charset="-120"/>
+              </a:rPr>
+              <a:t>03 · WHAT I WANTED</a:t>
+            </a:r>
+            <a:endParaRPr lang="en-US" sz="850" dirty="0"/>
+          </a:p>
+        </p:txBody>
+      </p:sp>
+      <p:sp>
+        <p:nvSpPr>
+          <p:cNvPr id="19" name="Text 17"/>
+          <p:cNvSpPr/>
+          <p:nvPr/>
+        </p:nvSpPr>
+        <p:spPr>
+          <a:xfrm>
+            <a:off x="8631936" y="1810512"/>
+            <a:ext cx="2724912" cy="2011680"/>
           </a:xfrm>
           <a:prstGeom prst="rect">
             <a:avLst/>
@@ -2271,40 +2519,23 @@
               <a:buNone/>
             </a:pPr>
             <a:r>
-              <a:rPr lang="en-US" sz="1120" dirty="0">
-                <a:solidFill>
-                  <a:srgbClr val="D9E6DC"/>
-                </a:solidFill>
-                <a:latin typeface="JetBrains Mono" pitchFamily="34" charset="0"/>
-                <a:ea typeface="JetBrains Mono" pitchFamily="34" charset="-122"/>
-                <a:cs typeface="JetBrains Mono" pitchFamily="34" charset="-120"/>
-              </a:rPr>
-              <a:t>0.25 CU × 730 h × $0.106</a:t>
-            </a:r>
-            <a:endParaRPr lang="en-US" sz="1120" dirty="0"/>
-          </a:p>
-          <a:p>
-            <a:pPr algn="l" indent="0" marL="0">
-              <a:buNone/>
-            </a:pPr>
-            <a:r>
-              <a:rPr lang="en-US" sz="1120" dirty="0">
-                <a:solidFill>
-                  <a:srgbClr val="D9E6DC"/>
-                </a:solidFill>
-                <a:latin typeface="JetBrains Mono" pitchFamily="34" charset="0"/>
-                <a:ea typeface="JetBrains Mono" pitchFamily="34" charset="-122"/>
-                <a:cs typeface="JetBrains Mono" pitchFamily="34" charset="-120"/>
-              </a:rPr>
-              <a:t>= $19.34 / project / month</a:t>
-            </a:r>
-            <a:endParaRPr lang="en-US" sz="1120" dirty="0"/>
-          </a:p>
-        </p:txBody>
-      </p:sp>
-      <p:sp>
-        <p:nvSpPr>
-          <p:cNvPr id="16" name="Text 14"/>
+              <a:rPr lang="en-US" sz="1900" b="1" dirty="0">
+                <a:solidFill>
+                  <a:srgbClr val="ECEFE9"/>
+                </a:solidFill>
+                <a:latin typeface="Inter" pitchFamily="34" charset="0"/>
+                <a:ea typeface="Inter" pitchFamily="34" charset="-122"/>
+                <a:cs typeface="Inter" pitchFamily="34" charset="-120"/>
+              </a:rPr>
+              <a:t>One server I own. A database per project in one click. Backups that prove they restore.</a:t>
+            </a:r>
+            <a:endParaRPr lang="en-US" sz="1900" dirty="0"/>
+          </a:p>
+        </p:txBody>
+      </p:sp>
+      <p:sp>
+        <p:nvSpPr>
+          <p:cNvPr id="20" name="Text 18"/>
           <p:cNvSpPr/>
           <p:nvPr/>
         </p:nvSpPr>
@@ -2337,7 +2568,7 @@
                 <a:ea typeface="Inter" pitchFamily="34" charset="-122"/>
                 <a:cs typeface="Inter" pitchFamily="34" charset="-120"/>
               </a:rPr>
-              <a:t>In the AI era we all ship niche apps for small audiences: many small databases, none of them big.</a:t>
+              <a:t>In the AI era we all ship niche apps for small audiences: many small databases, none of them big. That is what Pgfy is for.</a:t>
             </a:r>
             <a:endParaRPr lang="en-US" sz="1150" dirty="0"/>
           </a:p>
@@ -6732,7 +6963,7 @@
                 <a:ea typeface="Inter" pitchFamily="34" charset="-122"/>
                 <a:cs typeface="Inter" pitchFamily="34" charset="-120"/>
               </a:rPr>
-              <a:t>Second host + S3-compatible storage validation (AlphaVPS + Backblaze B2)</a:t>
+              <a:t>IPv6 and DNS-01 certificate issuance</a:t>
             </a:r>
             <a:endParaRPr lang="en-US" sz="1220" dirty="0"/>
           </a:p>
@@ -6773,7 +7004,7 @@
                 <a:ea typeface="Inter" pitchFamily="34" charset="-122"/>
                 <a:cs typeface="Inter" pitchFamily="34" charset="-120"/>
               </a:rPr>
-              <a:t>Everything here is listed as planned in the README — nothing on this slide is claimed as implemented.</a:t>
+              <a:t>Roadmap, straight from the README’s planned list.</a:t>
             </a:r>
             <a:endParaRPr lang="en-US" sz="1150" dirty="0"/>
           </a:p>
@@ -6915,8 +7146,8 @@
         </p:nvSpPr>
         <p:spPr>
           <a:xfrm>
-            <a:off x="749808" y="2331720"/>
-            <a:ext cx="8961120" cy="1600200"/>
+            <a:off x="749808" y="2286000"/>
+            <a:ext cx="10332720" cy="1188720"/>
           </a:xfrm>
           <a:prstGeom prst="rect">
             <a:avLst/>
@@ -6934,7 +7165,7 @@
               <a:buNone/>
             </a:pPr>
             <a:r>
-              <a:rPr lang="en-US" sz="3300" b="1" dirty="0">
+              <a:rPr lang="en-US" sz="3100" b="1" dirty="0">
                 <a:solidFill>
                   <a:srgbClr val="ECEFE9"/>
                 </a:solidFill>
@@ -6942,16 +7173,16 @@
                 <a:ea typeface="Inter" pitchFamily="34" charset="-122"/>
                 <a:cs typeface="Inter" pitchFamily="34" charset="-120"/>
               </a:rPr>
-              <a:t>Cheap enough to experiment.</a:t>
-            </a:r>
-            <a:endParaRPr lang="en-US" sz="3300" dirty="0"/>
+              <a:t>Every project’s database on one server you own.</a:t>
+            </a:r>
+            <a:endParaRPr lang="en-US" sz="3100" dirty="0"/>
           </a:p>
           <a:p>
             <a:pPr algn="l" indent="0" marL="0">
               <a:buNone/>
             </a:pPr>
             <a:r>
-              <a:rPr lang="en-US" sz="3300" b="1" dirty="0">
+              <a:rPr lang="en-US" sz="3100" b="1" dirty="0">
                 <a:solidFill>
                   <a:srgbClr val="ECEFE9"/>
                 </a:solidFill>
@@ -6959,32 +7190,56 @@
                 <a:ea typeface="Inter" pitchFamily="34" charset="-122"/>
                 <a:cs typeface="Inter" pitchFamily="34" charset="-120"/>
               </a:rPr>
-              <a:t>Honest about its limits.</a:t>
-            </a:r>
-            <a:endParaRPr lang="en-US" sz="3300" dirty="0"/>
-          </a:p>
+              <a:t>Backups that prove they restore.</a:t>
+            </a:r>
+            <a:endParaRPr lang="en-US" sz="3100" dirty="0"/>
+          </a:p>
+        </p:txBody>
+      </p:sp>
+      <p:sp>
+        <p:nvSpPr>
+          <p:cNvPr id="4" name="Text 2"/>
+          <p:cNvSpPr/>
+          <p:nvPr/>
+        </p:nvSpPr>
+        <p:spPr>
+          <a:xfrm>
+            <a:off x="749808" y="3584448"/>
+            <a:ext cx="10332720" cy="365760"/>
+          </a:xfrm>
+          <a:prstGeom prst="rect">
+            <a:avLst/>
+          </a:prstGeom>
+          <a:noFill/>
+          <a:ln/>
+        </p:spPr>
+        <p:txBody>
+          <a:bodyPr wrap="square" lIns="0" tIns="0" rIns="0" bIns="0" rtlCol="0" anchor="ctr">
+            <a:normAutofit/>
+          </a:bodyPr>
+          <a:lstStyle/>
           <a:p>
             <a:pPr algn="l" indent="0" marL="0">
               <a:buNone/>
             </a:pPr>
             <a:r>
-              <a:rPr lang="en-US" sz="3300" b="1" dirty="0">
-                <a:solidFill>
-                  <a:srgbClr val="ECEFE9"/>
-                </a:solidFill>
-                <a:latin typeface="Inter" pitchFamily="34" charset="0"/>
-                <a:ea typeface="Inter" pitchFamily="34" charset="-122"/>
-                <a:cs typeface="Inter" pitchFamily="34" charset="-120"/>
-              </a:rPr>
-              <a:t>A way out when you win.</a:t>
-            </a:r>
-            <a:endParaRPr lang="en-US" sz="3300" dirty="0"/>
-          </a:p>
-        </p:txBody>
-      </p:sp>
-      <p:sp>
-        <p:nvSpPr>
-          <p:cNvPr id="4" name="Text 2"/>
+              <a:rPr lang="en-US" sz="1400" dirty="0">
+                <a:solidFill>
+                  <a:srgbClr val="A2AAA0"/>
+                </a:solidFill>
+                <a:latin typeface="Inter" pitchFamily="34" charset="0"/>
+                <a:ea typeface="Inter" pitchFamily="34" charset="-122"/>
+                <a:cs typeface="Inter" pitchFamily="34" charset="-120"/>
+              </a:rPr>
+              <a:t>Open source · Go + React · PostgreSQL 18 · one-command install on Lightsail · backups to S3</a:t>
+            </a:r>
+            <a:endParaRPr lang="en-US" sz="1400" dirty="0"/>
+          </a:p>
+        </p:txBody>
+      </p:sp>
+      <p:sp>
+        <p:nvSpPr>
+          <p:cNvPr id="5" name="Text 3"/>
           <p:cNvSpPr/>
           <p:nvPr/>
         </p:nvSpPr>
@@ -7042,7 +7297,7 @@
       </p:sp>
       <p:sp>
         <p:nvSpPr>
-          <p:cNvPr id="5" name="Shape 3"/>
+          <p:cNvPr id="6" name="Shape 4"/>
           <p:cNvSpPr/>
           <p:nvPr/>
         </p:nvSpPr>
@@ -7069,7 +7324,7 @@
       </p:sp>
       <p:sp>
         <p:nvSpPr>
-          <p:cNvPr id="6" name="Text 4"/>
+          <p:cNvPr id="7" name="Text 5"/>
           <p:cNvSpPr/>
           <p:nvPr/>
         </p:nvSpPr>
@@ -7110,7 +7365,7 @@
       </p:sp>
       <p:sp>
         <p:nvSpPr>
-          <p:cNvPr id="7" name="Shape 5"/>
+          <p:cNvPr id="8" name="Shape 6"/>
           <p:cNvSpPr/>
           <p:nvPr/>
         </p:nvSpPr>
@@ -7137,7 +7392,7 @@
       </p:sp>
       <p:sp>
         <p:nvSpPr>
-          <p:cNvPr id="8" name="Text 6"/>
+          <p:cNvPr id="9" name="Text 7"/>
           <p:cNvSpPr/>
           <p:nvPr/>
         </p:nvSpPr>
@@ -7178,7 +7433,7 @@
       </p:sp>
       <p:sp>
         <p:nvSpPr>
-          <p:cNvPr id="9" name="Shape 7"/>
+          <p:cNvPr id="10" name="Shape 8"/>
           <p:cNvSpPr/>
           <p:nvPr/>
         </p:nvSpPr>
@@ -7205,7 +7460,7 @@
       </p:sp>
       <p:sp>
         <p:nvSpPr>
-          <p:cNvPr id="10" name="Text 8"/>
+          <p:cNvPr id="11" name="Text 9"/>
           <p:cNvSpPr/>
           <p:nvPr/>
         </p:nvSpPr>

</xml_diff>

<commit_message>
docs: capacity numbers measured on the $12 Lightsail instance; deck and script updated
Co-Authored-By: Claude Opus 5 <noreply@anthropic.com>
</commit_message>
<xml_diff>
--- a/docs/deck/pgfy-pitch.pptx
+++ b/docs/deck/pgfy-pitch.pptx
@@ -3901,7 +3901,7 @@
                 <a:ea typeface="Inter" pitchFamily="34" charset="-122"/>
                 <a:cs typeface="Inter" pitchFamily="34" charset="-120"/>
               </a:rPr>
-              <a:t>100 · 490 MiB in use</a:t>
+              <a:t>100 · 508 MiB in use</a:t>
             </a:r>
             <a:endParaRPr lang="en-US" sz="1800" dirty="0"/>
           </a:p>
@@ -4010,7 +4010,7 @@
                 <a:ea typeface="Inter" pitchFamily="34" charset="-122"/>
                 <a:cs typeface="Inter" pitchFamily="34" charset="-120"/>
               </a:rPr>
-              <a:t>943 tx/s · 8,866 reads/s</a:t>
+              <a:t>1,431 tx/s · 6,942 reads/s</a:t>
             </a:r>
             <a:endParaRPr lang="en-US" sz="1800" dirty="0"/>
           </a:p>
@@ -4119,7 +4119,7 @@
                 <a:ea typeface="Inter" pitchFamily="34" charset="-122"/>
                 <a:cs typeface="Inter" pitchFamily="34" charset="-120"/>
               </a:rPr>
-              <a:t>962 tx/s</a:t>
+              <a:t>1,252 tx/s</a:t>
             </a:r>
             <a:endParaRPr lang="en-US" sz="2400" dirty="0"/>
           </a:p>
@@ -5456,7 +5456,7 @@
                 <a:ea typeface="Inter" pitchFamily="34" charset="-122"/>
                 <a:cs typeface="Inter" pitchFamily="34" charset="-120"/>
               </a:rPr>
-              <a:t>Single-AZ · on-demand · us-east-1 · Sep 2026 · 90 GB of backups in S3 ≈ $2</a:t>
+              <a:t>Single-AZ · on-demand · us-east-1 · Sep 2026 · 90 GB of backups in S3 ≈ $2 · throughput measured on this $12 Lightsail instance</a:t>
             </a:r>
             <a:endParaRPr lang="en-US" sz="860" dirty="0"/>
           </a:p>

</xml_diff>